<commit_message>
Update presentation exclusively based on user text
- Update generate_presentation.py script and presentation.html slide deck
- Match exact financial breakdown: 2 980 800 KZT monthly revenue, 1 494 500 KZT net profit
- Include Discord boost cost 17 000 KZT, Telegram bot, 10% course discount and 20% referral code

Co-authored-by: sunder2290 <160613160+sunder2290@users.noreply.github.com>
</commit_message>
<xml_diff>
--- a/презентация_синтаксис.pptx
+++ b/презентация_синтаксис.pptx
@@ -3113,8 +3113,8 @@
         </p:nvSpPr>
         <p:spPr>
           <a:xfrm>
-            <a:off x="914400" y="1097280"/>
-            <a:ext cx="10362895" cy="4663440"/>
+            <a:off x="914400" y="914400"/>
+            <a:ext cx="10362895" cy="5029200"/>
           </a:xfrm>
           <a:prstGeom prst="rect">
             <a:avLst/>
@@ -3158,8 +3158,8 @@
         </p:nvSpPr>
         <p:spPr>
           <a:xfrm>
-            <a:off x="1371600" y="1463040"/>
-            <a:ext cx="9448495" cy="3931920"/>
+            <a:off x="1371600" y="1188720"/>
+            <a:ext cx="9448495" cy="4480560"/>
           </a:xfrm>
           <a:prstGeom prst="rect">
             <a:avLst/>
@@ -3173,59 +3173,63 @@
           <a:lstStyle/>
           <a:p>
             <a:pPr>
-              <a:defRPr sz="1400" b="1">
+              <a:defRPr sz="1300" b="1">
                 <a:solidFill>
                   <a:srgbClr val="D4A843"/>
                 </a:solidFill>
               </a:defRPr>
             </a:pPr>
             <a:r>
+              <a:t>Министерство просвещения РК | Управление образования области Улытау</a:t>
+            </a:r>
+            <a:br/>
+            <a:r>
               <a:t>КГКП «Жезказганский высший политехнический колледж»</a:t>
             </a:r>
           </a:p>
           <a:p>
             <a:pPr>
               <a:spcAft>
-                <a:spcPts val="2000"/>
+                <a:spcPts val="1800"/>
+              </a:spcAft>
+              <a:defRPr sz="1300">
+                <a:solidFill>
+                  <a:srgbClr val="AAB9CD"/>
+                </a:solidFill>
+              </a:defRPr>
+            </a:pPr>
+            <a:r>
+              <a:t>Специальность: Программное обеспечение</a:t>
+            </a:r>
+          </a:p>
+          <a:p>
+            <a:pPr>
+              <a:spcAft>
+                <a:spcPts val="2400"/>
+              </a:spcAft>
+              <a:defRPr sz="2800" b="1">
+                <a:solidFill>
+                  <a:srgbClr val="FFFFFF"/>
+                </a:solidFill>
+              </a:defRPr>
+            </a:pPr>
+            <a:r>
+              <a:t>Бизнес модель «Онлайн школа по программированию-Синтаксис»</a:t>
+            </a:r>
+          </a:p>
+          <a:p>
+            <a:pPr>
+              <a:spcAft>
+                <a:spcPts val="1400"/>
               </a:spcAft>
               <a:defRPr sz="1400">
                 <a:solidFill>
-                  <a:srgbClr val="AAB9CD"/>
-                </a:solidFill>
-              </a:defRPr>
-            </a:pPr>
-            <a:r>
-              <a:t>Специальность: Программное обеспечение</a:t>
-            </a:r>
-          </a:p>
-          <a:p>
-            <a:pPr>
-              <a:spcAft>
-                <a:spcPts val="3000"/>
-              </a:spcAft>
-              <a:defRPr sz="3000" b="1">
-                <a:solidFill>
-                  <a:srgbClr val="FFFFFF"/>
-                </a:solidFill>
-              </a:defRPr>
-            </a:pPr>
-            <a:r>
-              <a:t>Бизнес-модель «Онлайн-школа по программированию Синтаксис»</a:t>
-            </a:r>
-          </a:p>
-          <a:p>
-            <a:pPr>
-              <a:spcAft>
-                <a:spcPts val="1500"/>
-              </a:spcAft>
-              <a:defRPr sz="1400">
-                <a:solidFill>
                   <a:srgbClr val="F5F7FA"/>
                 </a:solidFill>
               </a:defRPr>
             </a:pPr>
             <a:r>
-              <a:t>Выполнили студенты группы ПО-32:</a:t>
+              <a:t>Выполнили: студенты группы ПО-32</a:t>
             </a:r>
             <a:br/>
             <a:r>
@@ -3284,8 +3288,8 @@
         </p:nvSpPr>
         <p:spPr>
           <a:xfrm>
-            <a:off x="731520" y="457200"/>
-            <a:ext cx="10698480" cy="365760"/>
+            <a:off x="731520" y="365760"/>
+            <a:ext cx="10698480" cy="320040"/>
           </a:xfrm>
           <a:prstGeom prst="rect">
             <a:avLst/>
@@ -3303,7 +3307,6 @@
                 <a:solidFill>
                   <a:srgbClr val="D4A843"/>
                 </a:solidFill>
-                <a:latin typeface="Arial"/>
               </a:defRPr>
             </a:pPr>
             <a:r>
@@ -3320,8 +3323,8 @@
         </p:nvSpPr>
         <p:spPr>
           <a:xfrm>
-            <a:off x="731520" y="777240"/>
-            <a:ext cx="10698480" cy="731520"/>
+            <a:off x="731520" y="685800"/>
+            <a:ext cx="10698480" cy="685800"/>
           </a:xfrm>
           <a:prstGeom prst="rect">
             <a:avLst/>
@@ -3335,15 +3338,14 @@
           <a:lstStyle/>
           <a:p>
             <a:pPr>
-              <a:defRPr sz="2600" b="1">
+              <a:defRPr sz="2400" b="1">
                 <a:solidFill>
                   <a:srgbClr val="FFFFFF"/>
                 </a:solidFill>
-                <a:latin typeface="Arial"/>
-              </a:defRPr>
-            </a:pPr>
-            <a:r>
-              <a:t>Заключение и Перспективы</a:t>
+              </a:defRPr>
+            </a:pPr>
+            <a:r>
+              <a:t>Заключение</a:t>
             </a:r>
           </a:p>
         </p:txBody>
@@ -3356,8 +3358,8 @@
         </p:nvSpPr>
         <p:spPr>
           <a:xfrm>
-            <a:off x="914400" y="1645920"/>
-            <a:ext cx="10362895" cy="4389120"/>
+            <a:off x="914400" y="1463040"/>
+            <a:ext cx="10362895" cy="4754880"/>
           </a:xfrm>
           <a:prstGeom prst="rect">
             <a:avLst/>
@@ -3401,8 +3403,8 @@
         </p:nvSpPr>
         <p:spPr>
           <a:xfrm>
-            <a:off x="1280160" y="2011680"/>
-            <a:ext cx="9631375" cy="3657600"/>
+            <a:off x="1280160" y="1828800"/>
+            <a:ext cx="9631375" cy="4023360"/>
           </a:xfrm>
           <a:prstGeom prst="rect">
             <a:avLst/>
@@ -3417,7 +3419,7 @@
           <a:p>
             <a:pPr>
               <a:spcAft>
-                <a:spcPts val="1000"/>
+                <a:spcPts val="1600"/>
               </a:spcAft>
               <a:defRPr sz="2200" b="1">
                 <a:solidFill>
@@ -3426,27 +3428,27 @@
               </a:defRPr>
             </a:pPr>
             <a:r>
-              <a:t>📌 Главный итог</a:t>
+              <a:t>📌 Подводя итог</a:t>
             </a:r>
           </a:p>
           <a:p>
             <a:pPr>
               <a:spcAft>
-                <a:spcPts val="2400"/>
+                <a:spcPts val="3600"/>
               </a:spcAft>
-              <a:defRPr sz="1600">
+              <a:defRPr sz="1800">
                 <a:solidFill>
                   <a:srgbClr val="F5F7FA"/>
                 </a:solidFill>
               </a:defRPr>
             </a:pPr>
             <a:r>
-              <a:t>Начав с аудитории 10–18 лет и заручившись поддержкой школ и вузов Казахстана, мы создаем прочный фундамент для последующего выхода на рынок взрослого образования и обучения практической работе с искусственным интеллектом.</a:t>
+              <a:t>При правильном выполнении указанных шагов, этот бизнес-проект вполне рентабелен и имеет высокий потенциал для успешного запуска и дальнейшего масштабирования.</a:t>
             </a:r>
           </a:p>
           <a:p>
             <a:pPr algn="ctr">
-              <a:defRPr sz="3200" b="1">
+              <a:defRPr sz="3600" b="1">
                 <a:solidFill>
                   <a:srgbClr val="1A8A8A"/>
                 </a:solidFill>
@@ -3492,8 +3494,8 @@
         </p:nvSpPr>
         <p:spPr>
           <a:xfrm>
-            <a:off x="731520" y="457200"/>
-            <a:ext cx="10698480" cy="365760"/>
+            <a:off x="731520" y="365760"/>
+            <a:ext cx="10698480" cy="320040"/>
           </a:xfrm>
           <a:prstGeom prst="rect">
             <a:avLst/>
@@ -3511,7 +3513,6 @@
                 <a:solidFill>
                   <a:srgbClr val="D4A843"/>
                 </a:solidFill>
-                <a:latin typeface="Arial"/>
               </a:defRPr>
             </a:pPr>
             <a:r>
@@ -3528,8 +3529,8 @@
         </p:nvSpPr>
         <p:spPr>
           <a:xfrm>
-            <a:off x="731520" y="777240"/>
-            <a:ext cx="10698480" cy="731520"/>
+            <a:off x="731520" y="685800"/>
+            <a:ext cx="10698480" cy="685800"/>
           </a:xfrm>
           <a:prstGeom prst="rect">
             <a:avLst/>
@@ -3543,15 +3544,14 @@
           <a:lstStyle/>
           <a:p>
             <a:pPr>
-              <a:defRPr sz="2600" b="1">
+              <a:defRPr sz="2400" b="1">
                 <a:solidFill>
                   <a:srgbClr val="FFFFFF"/>
                 </a:solidFill>
-                <a:latin typeface="Arial"/>
-              </a:defRPr>
-            </a:pPr>
-            <a:r>
-              <a:t>Ключевые ценности проекта</a:t>
+              </a:defRPr>
+            </a:pPr>
+            <a:r>
+              <a:t>1. Ключевые ценности</a:t>
             </a:r>
           </a:p>
         </p:txBody>
@@ -3564,8 +3564,8 @@
         </p:nvSpPr>
         <p:spPr>
           <a:xfrm>
-            <a:off x="731520" y="1645920"/>
-            <a:ext cx="10728655" cy="822960"/>
+            <a:off x="731520" y="1463040"/>
+            <a:ext cx="10728655" cy="868680"/>
           </a:xfrm>
           <a:prstGeom prst="rect">
             <a:avLst/>
@@ -3609,8 +3609,8 @@
         </p:nvSpPr>
         <p:spPr>
           <a:xfrm>
-            <a:off x="914400" y="1737360"/>
-            <a:ext cx="10362895" cy="640080"/>
+            <a:off x="914400" y="1554480"/>
+            <a:ext cx="10362895" cy="685800"/>
           </a:xfrm>
           <a:prstGeom prst="rect">
             <a:avLst/>
@@ -3643,7 +3643,7 @@
               </a:defRPr>
             </a:pPr>
             <a:r>
-              <a:t>Ежемесячная или разовая подписка, делающая обучение доступным и удобным для семей с любым бюджетом.</a:t>
+              <a:t>В виде ежемесячной или разовой подписки.</a:t>
             </a:r>
           </a:p>
         </p:txBody>
@@ -3656,8 +3656,8 @@
         </p:nvSpPr>
         <p:spPr>
           <a:xfrm>
-            <a:off x="731520" y="2606040"/>
-            <a:ext cx="10728655" cy="822960"/>
+            <a:off x="731520" y="2450592"/>
+            <a:ext cx="10728655" cy="868680"/>
           </a:xfrm>
           <a:prstGeom prst="rect">
             <a:avLst/>
@@ -3701,8 +3701,8 @@
         </p:nvSpPr>
         <p:spPr>
           <a:xfrm>
-            <a:off x="914400" y="2697480"/>
-            <a:ext cx="10362895" cy="640080"/>
+            <a:off x="914400" y="2542032"/>
+            <a:ext cx="10362895" cy="685800"/>
           </a:xfrm>
           <a:prstGeom prst="rect">
             <a:avLst/>
@@ -3723,7 +3723,7 @@
               </a:defRPr>
             </a:pPr>
             <a:r>
-              <a:t>🔍 Полная прозрачность</a:t>
+              <a:t>🔍 Полная прозрачность обучения</a:t>
             </a:r>
           </a:p>
           <a:p>
@@ -3735,7 +3735,7 @@
               </a:defRPr>
             </a:pPr>
             <a:r>
-              <a:t>Открытый доступ к материалам, четкие критерии оценки и регулярный контроль прогресса.</a:t>
+              <a:t>Честный подход без ложных обещаний «легкого программирования».</a:t>
             </a:r>
           </a:p>
         </p:txBody>
@@ -3748,8 +3748,8 @@
         </p:nvSpPr>
         <p:spPr>
           <a:xfrm>
-            <a:off x="731520" y="3566160"/>
-            <a:ext cx="10728655" cy="822960"/>
+            <a:off x="731520" y="3438144"/>
+            <a:ext cx="10728655" cy="868680"/>
           </a:xfrm>
           <a:prstGeom prst="rect">
             <a:avLst/>
@@ -3793,8 +3793,8 @@
         </p:nvSpPr>
         <p:spPr>
           <a:xfrm>
-            <a:off x="914400" y="3657600"/>
-            <a:ext cx="10362895" cy="640080"/>
+            <a:off x="914400" y="3529584"/>
+            <a:ext cx="10362895" cy="685800"/>
           </a:xfrm>
           <a:prstGeom prst="rect">
             <a:avLst/>
@@ -3815,7 +3815,7 @@
               </a:defRPr>
             </a:pPr>
             <a:r>
-              <a:t>🤝 Комфортная среда</a:t>
+              <a:t>💻 Акцент на практику</a:t>
             </a:r>
           </a:p>
           <a:p>
@@ -3827,7 +3827,7 @@
               </a:defRPr>
             </a:pPr>
             <a:r>
-              <a:t>Создание дружелюбных условий, поддерживающих мотивацию и вовлеченность каждого ученика.</a:t>
+              <a:t>Упор на практические навыки (70% практики / 30% теории) в программе.</a:t>
             </a:r>
           </a:p>
         </p:txBody>
@@ -3840,8 +3840,8 @@
         </p:nvSpPr>
         <p:spPr>
           <a:xfrm>
-            <a:off x="731520" y="4526280"/>
-            <a:ext cx="10728655" cy="822960"/>
+            <a:off x="731520" y="4425696"/>
+            <a:ext cx="10728655" cy="868680"/>
           </a:xfrm>
           <a:prstGeom prst="rect">
             <a:avLst/>
@@ -3885,8 +3885,8 @@
         </p:nvSpPr>
         <p:spPr>
           <a:xfrm>
-            <a:off x="914400" y="4617720"/>
-            <a:ext cx="10362895" cy="640080"/>
+            <a:off x="914400" y="4517136"/>
+            <a:ext cx="10362895" cy="685800"/>
           </a:xfrm>
           <a:prstGeom prst="rect">
             <a:avLst/>
@@ -3907,7 +3907,7 @@
               </a:defRPr>
             </a:pPr>
             <a:r>
-              <a:t>🏆 Практика &amp; Хакатоны</a:t>
+              <a:t>🏆 Мотивация и Хакатоны</a:t>
             </a:r>
           </a:p>
           <a:p>
@@ -3919,7 +3919,7 @@
               </a:defRPr>
             </a:pPr>
             <a:r>
-              <a:t>Мотивация студентов проверять полученные навыки на реальных командных хакатонах и соревнованиях.</a:t>
+              <a:t>Мотивация студентов проверять полученные знания в различных «Хакатонах».</a:t>
             </a:r>
           </a:p>
         </p:txBody>
@@ -3932,8 +3932,8 @@
         </p:nvSpPr>
         <p:spPr>
           <a:xfrm>
-            <a:off x="731520" y="5486400"/>
-            <a:ext cx="10728655" cy="822960"/>
+            <a:off x="731520" y="5413248"/>
+            <a:ext cx="10728655" cy="868680"/>
           </a:xfrm>
           <a:prstGeom prst="rect">
             <a:avLst/>
@@ -3977,8 +3977,8 @@
         </p:nvSpPr>
         <p:spPr>
           <a:xfrm>
-            <a:off x="914400" y="5577840"/>
-            <a:ext cx="10362895" cy="640080"/>
+            <a:off x="914400" y="5504688"/>
+            <a:ext cx="10362895" cy="685800"/>
           </a:xfrm>
           <a:prstGeom prst="rect">
             <a:avLst/>
@@ -4011,7 +4011,7 @@
               </a:defRPr>
             </a:pPr>
             <a:r>
-              <a:t>Выдача персонального сертификата с верификацией подлинности через QR-код.</a:t>
+              <a:t>Выдача официального документа об окончании с проверкой подлинности через QR-код.</a:t>
             </a:r>
           </a:p>
         </p:txBody>
@@ -4050,8 +4050,8 @@
         </p:nvSpPr>
         <p:spPr>
           <a:xfrm>
-            <a:off x="731520" y="457200"/>
-            <a:ext cx="10698480" cy="365760"/>
+            <a:off x="731520" y="365760"/>
+            <a:ext cx="10698480" cy="320040"/>
           </a:xfrm>
           <a:prstGeom prst="rect">
             <a:avLst/>
@@ -4069,7 +4069,6 @@
                 <a:solidFill>
                   <a:srgbClr val="D4A843"/>
                 </a:solidFill>
-                <a:latin typeface="Arial"/>
               </a:defRPr>
             </a:pPr>
             <a:r>
@@ -4086,8 +4085,8 @@
         </p:nvSpPr>
         <p:spPr>
           <a:xfrm>
-            <a:off x="731520" y="777240"/>
-            <a:ext cx="10698480" cy="731520"/>
+            <a:off x="731520" y="685800"/>
+            <a:ext cx="10698480" cy="685800"/>
           </a:xfrm>
           <a:prstGeom prst="rect">
             <a:avLst/>
@@ -4101,15 +4100,14 @@
           <a:lstStyle/>
           <a:p>
             <a:pPr>
-              <a:defRPr sz="2600" b="1">
+              <a:defRPr sz="2400" b="1">
                 <a:solidFill>
                   <a:srgbClr val="FFFFFF"/>
                 </a:solidFill>
-                <a:latin typeface="Arial"/>
-              </a:defRPr>
-            </a:pPr>
-            <a:r>
-              <a:t>Сегменты потребителей</a:t>
+              </a:defRPr>
+            </a:pPr>
+            <a:r>
+              <a:t>2. Сегменты потребителей</a:t>
             </a:r>
           </a:p>
         </p:txBody>
@@ -4122,8 +4120,8 @@
         </p:nvSpPr>
         <p:spPr>
           <a:xfrm>
-            <a:off x="731520" y="1645920"/>
-            <a:ext cx="5212080" cy="4572000"/>
+            <a:off x="731520" y="1463040"/>
+            <a:ext cx="5212080" cy="4754880"/>
           </a:xfrm>
           <a:prstGeom prst="rect">
             <a:avLst/>
@@ -4167,8 +4165,8 @@
         </p:nvSpPr>
         <p:spPr>
           <a:xfrm>
-            <a:off x="1005840" y="1920240"/>
-            <a:ext cx="4663440" cy="4023360"/>
+            <a:off x="1005840" y="1737360"/>
+            <a:ext cx="4663440" cy="4206240"/>
           </a:xfrm>
           <a:prstGeom prst="rect">
             <a:avLst/>
@@ -4204,13 +4202,13 @@
               </a:defRPr>
             </a:pPr>
             <a:r>
-              <a:t>• Дети и подростки (10–18 лет)</a:t>
+              <a:t>• Дети и подростки от 10 до 18 лет</a:t>
             </a:r>
           </a:p>
           <a:p>
             <a:pPr>
               <a:spcAft>
-                <a:spcPts val="1200"/>
+                <a:spcPts val="1400"/>
               </a:spcAft>
               <a:defRPr sz="1300">
                 <a:solidFill>
@@ -4219,7 +4217,7 @@
               </a:defRPr>
             </a:pPr>
             <a:r>
-              <a:t>Основная целевая аудитория, желающая освоить программирование, веб-разработку и IT-навыки.</a:t>
+              <a:t>Основная аудитория учеников, стремящихся научиться программированию и цифровой грамотности.</a:t>
             </a:r>
           </a:p>
           <a:p>
@@ -4231,13 +4229,13 @@
               </a:defRPr>
             </a:pPr>
             <a:r>
-              <a:t>• Родители учеников</a:t>
+              <a:t>• Их родители</a:t>
             </a:r>
           </a:p>
           <a:p>
             <a:pPr>
               <a:spcAft>
-                <a:spcPts val="1200"/>
+                <a:spcPts val="1400"/>
               </a:spcAft>
               <a:defRPr sz="1300">
                 <a:solidFill>
@@ -4246,7 +4244,7 @@
               </a:defRPr>
             </a:pPr>
             <a:r>
-              <a:t>Лица, принимающие решение и оплачивающие обучение. Заинтересованы в полезном досуге и перспективной профессии для ребенка.</a:t>
+              <a:t>Заинтересованы в полезном досуге и будущей профессии ребенка.</a:t>
             </a:r>
           </a:p>
         </p:txBody>
@@ -4259,8 +4257,8 @@
         </p:nvSpPr>
         <p:spPr>
           <a:xfrm>
-            <a:off x="6248095" y="1645920"/>
-            <a:ext cx="5212080" cy="4572000"/>
+            <a:off x="6248095" y="1463040"/>
+            <a:ext cx="5212080" cy="4754880"/>
           </a:xfrm>
           <a:prstGeom prst="rect">
             <a:avLst/>
@@ -4304,8 +4302,8 @@
         </p:nvSpPr>
         <p:spPr>
           <a:xfrm>
-            <a:off x="6522415" y="1920240"/>
-            <a:ext cx="4663440" cy="4023360"/>
+            <a:off x="6522415" y="1737360"/>
+            <a:ext cx="4663440" cy="4206240"/>
           </a:xfrm>
           <a:prstGeom prst="rect">
             <a:avLst/>
@@ -4329,7 +4327,7 @@
               </a:defRPr>
             </a:pPr>
             <a:r>
-              <a:t>🚀 Стратегия масштабирования</a:t>
+              <a:t>🚀 Стратегический план</a:t>
             </a:r>
           </a:p>
           <a:p>
@@ -4341,13 +4339,13 @@
               </a:defRPr>
             </a:pPr>
             <a:r>
-              <a:t>• Взрослая аудитория</a:t>
+              <a:t>• Курсы для взрослой аудитории</a:t>
             </a:r>
           </a:p>
           <a:p>
             <a:pPr>
               <a:spcAft>
-                <a:spcPts val="1200"/>
+                <a:spcPts val="1400"/>
               </a:spcAft>
               <a:defRPr sz="1300">
                 <a:solidFill>
@@ -4356,7 +4354,7 @@
               </a:defRPr>
             </a:pPr>
             <a:r>
-              <a:t>Люди, стремящиеся сменить специальность и войти в IT-сферу с нуля.</a:t>
+              <a:t>При масштабировании проекта — помощь тем, кому нужна смена специальности.</a:t>
             </a:r>
           </a:p>
           <a:p>
@@ -4368,13 +4366,13 @@
               </a:defRPr>
             </a:pPr>
             <a:r>
-              <a:t>• Работа с ИИ (AI Literacy)</a:t>
+              <a:t>• Грамотность в работе с ИИ</a:t>
             </a:r>
           </a:p>
           <a:p>
             <a:pPr>
               <a:spcAft>
-                <a:spcPts val="1200"/>
+                <a:spcPts val="1400"/>
               </a:spcAft>
               <a:defRPr sz="1300">
                 <a:solidFill>
@@ -4383,7 +4381,7 @@
               </a:defRPr>
             </a:pPr>
             <a:r>
-              <a:t>Курсы по грамотному применению искусственного интеллекта и нейросетей в профессиональной деятельности.</a:t>
+              <a:t>Обучение работе с искусственным интеллектом для взрослых и специалистов.</a:t>
             </a:r>
           </a:p>
         </p:txBody>
@@ -4422,8 +4420,8 @@
         </p:nvSpPr>
         <p:spPr>
           <a:xfrm>
-            <a:off x="731520" y="457200"/>
-            <a:ext cx="10698480" cy="365760"/>
+            <a:off x="731520" y="365760"/>
+            <a:ext cx="10698480" cy="320040"/>
           </a:xfrm>
           <a:prstGeom prst="rect">
             <a:avLst/>
@@ -4441,7 +4439,6 @@
                 <a:solidFill>
                   <a:srgbClr val="D4A843"/>
                 </a:solidFill>
-                <a:latin typeface="Arial"/>
               </a:defRPr>
             </a:pPr>
             <a:r>
@@ -4458,8 +4455,8 @@
         </p:nvSpPr>
         <p:spPr>
           <a:xfrm>
-            <a:off x="731520" y="777240"/>
-            <a:ext cx="10698480" cy="731520"/>
+            <a:off x="731520" y="685800"/>
+            <a:ext cx="10698480" cy="685800"/>
           </a:xfrm>
           <a:prstGeom prst="rect">
             <a:avLst/>
@@ -4473,15 +4470,14 @@
           <a:lstStyle/>
           <a:p>
             <a:pPr>
-              <a:defRPr sz="2600" b="1">
+              <a:defRPr sz="2400" b="1">
                 <a:solidFill>
                   <a:srgbClr val="FFFFFF"/>
                 </a:solidFill>
-                <a:latin typeface="Arial"/>
-              </a:defRPr>
-            </a:pPr>
-            <a:r>
-              <a:t>Каналы взаимодействия и Отношения с клиентами</a:t>
+              </a:defRPr>
+            </a:pPr>
+            <a:r>
+              <a:t>3. Каналы взаимодействия</a:t>
             </a:r>
           </a:p>
         </p:txBody>
@@ -4494,8 +4490,8 @@
         </p:nvSpPr>
         <p:spPr>
           <a:xfrm>
-            <a:off x="731520" y="1645920"/>
-            <a:ext cx="5212080" cy="4572000"/>
+            <a:off x="731520" y="1463040"/>
+            <a:ext cx="5212080" cy="2286000"/>
           </a:xfrm>
           <a:prstGeom prst="rect">
             <a:avLst/>
@@ -4539,8 +4535,8 @@
         </p:nvSpPr>
         <p:spPr>
           <a:xfrm>
-            <a:off x="1005840" y="1920240"/>
-            <a:ext cx="4663440" cy="4023360"/>
+            <a:off x="960120" y="1645920"/>
+            <a:ext cx="4754880" cy="1920240"/>
           </a:xfrm>
           <a:prstGeom prst="rect">
             <a:avLst/>
@@ -4554,98 +4550,41 @@
           <a:lstStyle/>
           <a:p>
             <a:pPr>
+              <a:defRPr sz="1700" b="1">
+                <a:solidFill>
+                  <a:srgbClr val="D4A843"/>
+                </a:solidFill>
+              </a:defRPr>
+            </a:pPr>
+            <a:r>
+              <a:t>🎧 Discord</a:t>
+            </a:r>
+          </a:p>
+          <a:p>
+            <a:pPr>
               <a:spcAft>
-                <a:spcPts val="1400"/>
+                <a:spcPts val="600"/>
               </a:spcAft>
-              <a:defRPr sz="2000" b="1">
-                <a:solidFill>
-                  <a:srgbClr val="D4A843"/>
-                </a:solidFill>
-              </a:defRPr>
-            </a:pPr>
-            <a:r>
-              <a:t>📢 Каналы взаимодействия</a:t>
-            </a:r>
-          </a:p>
-          <a:p>
-            <a:pPr>
-              <a:defRPr sz="1500" b="1">
-                <a:solidFill>
-                  <a:srgbClr val="FFFFFF"/>
-                </a:solidFill>
-              </a:defRPr>
-            </a:pPr>
-            <a:r>
-              <a:t>• Социальные сети &amp; Сообщества</a:t>
-            </a:r>
-          </a:p>
-          <a:p>
-            <a:pPr>
-              <a:spcAft>
-                <a:spcPts val="1000"/>
-              </a:spcAft>
-              <a:defRPr sz="1300">
-                <a:solidFill>
-                  <a:srgbClr val="AAB9CD"/>
-                </a:solidFill>
-              </a:defRPr>
-            </a:pPr>
-            <a:r>
-              <a:t>Instagram, Discord, YouTube, TikTok для охвата молодежи.</a:t>
-            </a:r>
-          </a:p>
-          <a:p>
-            <a:pPr>
-              <a:defRPr sz="1500" b="1">
-                <a:solidFill>
-                  <a:srgbClr val="FFFFFF"/>
-                </a:solidFill>
-              </a:defRPr>
-            </a:pPr>
-            <a:r>
-              <a:t>• Партнерские сети</a:t>
-            </a:r>
-          </a:p>
-          <a:p>
-            <a:pPr>
-              <a:spcAft>
-                <a:spcPts val="1000"/>
-              </a:spcAft>
-              <a:defRPr sz="1300">
-                <a:solidFill>
-                  <a:srgbClr val="AAB9CD"/>
-                </a:solidFill>
-              </a:defRPr>
-            </a:pPr>
-            <a:r>
-              <a:t>Сотрудничество со школами и вузами Казахстана.</a:t>
-            </a:r>
-          </a:p>
-          <a:p>
-            <a:pPr>
-              <a:defRPr sz="1500" b="1">
-                <a:solidFill>
-                  <a:srgbClr val="FFFFFF"/>
-                </a:solidFill>
-              </a:defRPr>
-            </a:pPr>
-            <a:r>
-              <a:t>• Офлайн-продвижение</a:t>
-            </a:r>
-          </a:p>
-          <a:p>
-            <a:pPr>
-              <a:spcAft>
-                <a:spcPts val="1000"/>
-              </a:spcAft>
-              <a:defRPr sz="1300">
-                <a:solidFill>
-                  <a:srgbClr val="AAB9CD"/>
-                </a:solidFill>
-              </a:defRPr>
-            </a:pPr>
-            <a:r>
-              <a:t>Работа промоутеров и распространение информационных материалов.</a:t>
+              <a:defRPr sz="1200" b="1">
+                <a:solidFill>
+                  <a:srgbClr val="1A8A8A"/>
+                </a:solidFill>
+              </a:defRPr>
+            </a:pPr>
+            <a:r>
+              <a:t>Уроки &amp; Демонстрация</a:t>
+            </a:r>
+          </a:p>
+          <a:p>
+            <a:pPr>
+              <a:defRPr sz="1200">
+                <a:solidFill>
+                  <a:srgbClr val="F5F7FA"/>
+                </a:solidFill>
+              </a:defRPr>
+            </a:pPr>
+            <a:r>
+              <a:t>Платформа с удобными функциями и голосовыми чатами для проведения онлайн-уроков, демонстрации экрана наставнику в хорошем качестве — абсолютно необходимая функция для работы.</a:t>
             </a:r>
           </a:p>
         </p:txBody>
@@ -4658,8 +4597,8 @@
         </p:nvSpPr>
         <p:spPr>
           <a:xfrm>
-            <a:off x="6248095" y="1645920"/>
-            <a:ext cx="5212080" cy="4572000"/>
+            <a:off x="6248095" y="1463040"/>
+            <a:ext cx="5212080" cy="2286000"/>
           </a:xfrm>
           <a:prstGeom prst="rect">
             <a:avLst/>
@@ -4703,8 +4642,8 @@
         </p:nvSpPr>
         <p:spPr>
           <a:xfrm>
-            <a:off x="6522415" y="1920240"/>
-            <a:ext cx="4663440" cy="4023360"/>
+            <a:off x="6476695" y="1645920"/>
+            <a:ext cx="4754880" cy="1920240"/>
           </a:xfrm>
           <a:prstGeom prst="rect">
             <a:avLst/>
@@ -4718,98 +4657,255 @@
           <a:lstStyle/>
           <a:p>
             <a:pPr>
+              <a:defRPr sz="1700" b="1">
+                <a:solidFill>
+                  <a:srgbClr val="D4A843"/>
+                </a:solidFill>
+              </a:defRPr>
+            </a:pPr>
+            <a:r>
+              <a:t>📱 Instagram, Telegram, TikTok</a:t>
+            </a:r>
+          </a:p>
+          <a:p>
+            <a:pPr>
               <a:spcAft>
-                <a:spcPts val="1400"/>
+                <a:spcPts val="600"/>
               </a:spcAft>
-              <a:defRPr sz="2000" b="1">
+              <a:defRPr sz="1200" b="1">
                 <a:solidFill>
                   <a:srgbClr val="1A8A8A"/>
                 </a:solidFill>
               </a:defRPr>
             </a:pPr>
             <a:r>
-              <a:t>🤝 Отношения с клиентами</a:t>
-            </a:r>
-          </a:p>
-          <a:p>
-            <a:pPr>
-              <a:defRPr sz="1500" b="1">
-                <a:solidFill>
-                  <a:srgbClr val="FFFFFF"/>
-                </a:solidFill>
-              </a:defRPr>
-            </a:pPr>
-            <a:r>
-              <a:t>• Геймификация и интерактив</a:t>
+              <a:t>Продвижение &amp; Реклама</a:t>
+            </a:r>
+          </a:p>
+          <a:p>
+            <a:pPr>
+              <a:defRPr sz="1200">
+                <a:solidFill>
+                  <a:srgbClr val="F5F7FA"/>
+                </a:solidFill>
+              </a:defRPr>
+            </a:pPr>
+            <a:r>
+              <a:t>Площадки с высокой концентрацией молодой и взрослой аудитории, где проще всего разместить рекламу и привлечь целевой интерес.</a:t>
+            </a:r>
+          </a:p>
+        </p:txBody>
+      </p:sp>
+      <p:sp>
+        <p:nvSpPr>
+          <p:cNvPr id="8" name="Rectangle 7"/>
+          <p:cNvSpPr/>
+          <p:nvPr/>
+        </p:nvSpPr>
+        <p:spPr>
+          <a:xfrm>
+            <a:off x="731520" y="3931920"/>
+            <a:ext cx="5212080" cy="2286000"/>
+          </a:xfrm>
+          <a:prstGeom prst="rect">
+            <a:avLst/>
+          </a:prstGeom>
+          <a:solidFill>
+            <a:srgbClr val="12233C"/>
+          </a:solidFill>
+          <a:ln w="12700">
+            <a:solidFill>
+              <a:srgbClr val="233C5F"/>
+            </a:solidFill>
+          </a:ln>
+        </p:spPr>
+        <p:style>
+          <a:lnRef idx="1">
+            <a:schemeClr val="accent1"/>
+          </a:lnRef>
+          <a:fillRef idx="3">
+            <a:schemeClr val="accent1"/>
+          </a:fillRef>
+          <a:effectRef idx="2">
+            <a:schemeClr val="accent1"/>
+          </a:effectRef>
+          <a:fontRef idx="minor">
+            <a:schemeClr val="lt1"/>
+          </a:fontRef>
+        </p:style>
+        <p:txBody>
+          <a:bodyPr rtlCol="0" anchor="ctr"/>
+          <a:lstStyle/>
+          <a:p>
+            <a:pPr algn="ctr"/>
+          </a:p>
+        </p:txBody>
+      </p:sp>
+      <p:sp>
+        <p:nvSpPr>
+          <p:cNvPr id="9" name="TextBox 8"/>
+          <p:cNvSpPr txBox="1"/>
+          <p:nvPr/>
+        </p:nvSpPr>
+        <p:spPr>
+          <a:xfrm>
+            <a:off x="960120" y="4114800"/>
+            <a:ext cx="4754880" cy="1920240"/>
+          </a:xfrm>
+          <a:prstGeom prst="rect">
+            <a:avLst/>
+          </a:prstGeom>
+          <a:noFill/>
+        </p:spPr>
+        <p:txBody>
+          <a:bodyPr wrap="square">
+            <a:spAutoFit/>
+          </a:bodyPr>
+          <a:lstStyle/>
+          <a:p>
+            <a:pPr>
+              <a:defRPr sz="1700" b="1">
+                <a:solidFill>
+                  <a:srgbClr val="D4A843"/>
+                </a:solidFill>
+              </a:defRPr>
+            </a:pPr>
+            <a:r>
+              <a:t>🏫 Школы Казахстана</a:t>
             </a:r>
           </a:p>
           <a:p>
             <a:pPr>
               <a:spcAft>
-                <a:spcPts val="1000"/>
+                <a:spcPts val="600"/>
               </a:spcAft>
-              <a:defRPr sz="1300">
-                <a:solidFill>
-                  <a:srgbClr val="AAB9CD"/>
-                </a:solidFill>
-              </a:defRPr>
-            </a:pPr>
-            <a:r>
-              <a:t>Вовлечение и удержание внимания детей через интерактивный формат.</a:t>
-            </a:r>
-          </a:p>
-          <a:p>
-            <a:pPr>
-              <a:defRPr sz="1500" b="1">
-                <a:solidFill>
-                  <a:srgbClr val="FFFFFF"/>
-                </a:solidFill>
-              </a:defRPr>
-            </a:pPr>
-            <a:r>
-              <a:t>• Отчетность для родителей</a:t>
+              <a:defRPr sz="1200" b="1">
+                <a:solidFill>
+                  <a:srgbClr val="1A8A8A"/>
+                </a:solidFill>
+              </a:defRPr>
+            </a:pPr>
+            <a:r>
+              <a:t>Сотрудничество &amp; Продвижение</a:t>
+            </a:r>
+          </a:p>
+          <a:p>
+            <a:pPr>
+              <a:defRPr sz="1200">
+                <a:solidFill>
+                  <a:srgbClr val="F5F7FA"/>
+                </a:solidFill>
+              </a:defRPr>
+            </a:pPr>
+            <a:r>
+              <a:t>Партнерство со школами, так как подростки ищут возможности обучиться актуальному программированию взамен устаревших программ конкуррентов.</a:t>
+            </a:r>
+          </a:p>
+        </p:txBody>
+      </p:sp>
+      <p:sp>
+        <p:nvSpPr>
+          <p:cNvPr id="10" name="Rectangle 9"/>
+          <p:cNvSpPr/>
+          <p:nvPr/>
+        </p:nvSpPr>
+        <p:spPr>
+          <a:xfrm>
+            <a:off x="6248095" y="3931920"/>
+            <a:ext cx="5212080" cy="2286000"/>
+          </a:xfrm>
+          <a:prstGeom prst="rect">
+            <a:avLst/>
+          </a:prstGeom>
+          <a:solidFill>
+            <a:srgbClr val="12233C"/>
+          </a:solidFill>
+          <a:ln w="12700">
+            <a:solidFill>
+              <a:srgbClr val="233C5F"/>
+            </a:solidFill>
+          </a:ln>
+        </p:spPr>
+        <p:style>
+          <a:lnRef idx="1">
+            <a:schemeClr val="accent1"/>
+          </a:lnRef>
+          <a:fillRef idx="3">
+            <a:schemeClr val="accent1"/>
+          </a:fillRef>
+          <a:effectRef idx="2">
+            <a:schemeClr val="accent1"/>
+          </a:effectRef>
+          <a:fontRef idx="minor">
+            <a:schemeClr val="lt1"/>
+          </a:fontRef>
+        </p:style>
+        <p:txBody>
+          <a:bodyPr rtlCol="0" anchor="ctr"/>
+          <a:lstStyle/>
+          <a:p>
+            <a:pPr algn="ctr"/>
+          </a:p>
+        </p:txBody>
+      </p:sp>
+      <p:sp>
+        <p:nvSpPr>
+          <p:cNvPr id="11" name="TextBox 10"/>
+          <p:cNvSpPr txBox="1"/>
+          <p:nvPr/>
+        </p:nvSpPr>
+        <p:spPr>
+          <a:xfrm>
+            <a:off x="6476695" y="4114800"/>
+            <a:ext cx="4754880" cy="1920240"/>
+          </a:xfrm>
+          <a:prstGeom prst="rect">
+            <a:avLst/>
+          </a:prstGeom>
+          <a:noFill/>
+        </p:spPr>
+        <p:txBody>
+          <a:bodyPr wrap="square">
+            <a:spAutoFit/>
+          </a:bodyPr>
+          <a:lstStyle/>
+          <a:p>
+            <a:pPr>
+              <a:defRPr sz="1700" b="1">
+                <a:solidFill>
+                  <a:srgbClr val="D4A843"/>
+                </a:solidFill>
+              </a:defRPr>
+            </a:pPr>
+            <a:r>
+              <a:t>🚶‍♂️ Промоутеры</a:t>
             </a:r>
           </a:p>
           <a:p>
             <a:pPr>
               <a:spcAft>
-                <a:spcPts val="1000"/>
+                <a:spcPts val="600"/>
               </a:spcAft>
-              <a:defRPr sz="1300">
-                <a:solidFill>
-                  <a:srgbClr val="AAB9CD"/>
-                </a:solidFill>
-              </a:defRPr>
-            </a:pPr>
-            <a:r>
-              <a:t>Ежемесячные отчеты об успеваемости и личном прогрессе каждого ребенка.</a:t>
-            </a:r>
-          </a:p>
-          <a:p>
-            <a:pPr>
-              <a:defRPr sz="1500" b="1">
-                <a:solidFill>
-                  <a:srgbClr val="FFFFFF"/>
-                </a:solidFill>
-              </a:defRPr>
-            </a:pPr>
-            <a:r>
-              <a:t>• Контроль и дисциплина</a:t>
-            </a:r>
-          </a:p>
-          <a:p>
-            <a:pPr>
-              <a:spcAft>
-                <a:spcPts val="1000"/>
-              </a:spcAft>
-              <a:defRPr sz="1300">
-                <a:solidFill>
-                  <a:srgbClr val="AAB9CD"/>
-                </a:solidFill>
-              </a:defRPr>
-            </a:pPr>
-            <a:r>
-              <a:t>Доступ к следующему месяцу открывается только после оплаты — дисциплинирует учеников и снижает отвал.</a:t>
+              <a:defRPr sz="1200" b="1">
+                <a:solidFill>
+                  <a:srgbClr val="1A8A8A"/>
+                </a:solidFill>
+              </a:defRPr>
+            </a:pPr>
+            <a:r>
+              <a:t>Офлайн-активность</a:t>
+            </a:r>
+          </a:p>
+          <a:p>
+            <a:pPr>
+              <a:defRPr sz="1200">
+                <a:solidFill>
+                  <a:srgbClr val="F5F7FA"/>
+                </a:solidFill>
+              </a:defRPr>
+            </a:pPr>
+            <a:r>
+              <a:t>Работа промоутеров для локального распространения информации и прямого привлечения.</a:t>
             </a:r>
           </a:p>
         </p:txBody>
@@ -4848,8 +4944,8 @@
         </p:nvSpPr>
         <p:spPr>
           <a:xfrm>
-            <a:off x="731520" y="457200"/>
-            <a:ext cx="10698480" cy="365760"/>
+            <a:off x="731520" y="365760"/>
+            <a:ext cx="10698480" cy="320040"/>
           </a:xfrm>
           <a:prstGeom prst="rect">
             <a:avLst/>
@@ -4867,7 +4963,6 @@
                 <a:solidFill>
                   <a:srgbClr val="D4A843"/>
                 </a:solidFill>
-                <a:latin typeface="Arial"/>
               </a:defRPr>
             </a:pPr>
             <a:r>
@@ -4884,8 +4979,8 @@
         </p:nvSpPr>
         <p:spPr>
           <a:xfrm>
-            <a:off x="731520" y="777240"/>
-            <a:ext cx="10698480" cy="731520"/>
+            <a:off x="731520" y="685800"/>
+            <a:ext cx="10698480" cy="685800"/>
           </a:xfrm>
           <a:prstGeom prst="rect">
             <a:avLst/>
@@ -4899,15 +4994,14 @@
           <a:lstStyle/>
           <a:p>
             <a:pPr>
-              <a:defRPr sz="2600" b="1">
+              <a:defRPr sz="2400" b="1">
                 <a:solidFill>
                   <a:srgbClr val="FFFFFF"/>
                 </a:solidFill>
-                <a:latin typeface="Arial"/>
-              </a:defRPr>
-            </a:pPr>
-            <a:r>
-              <a:t>Потоки доходов и Направления обучения</a:t>
+              </a:defRPr>
+            </a:pPr>
+            <a:r>
+              <a:t>4. Отношения с клиентами</a:t>
             </a:r>
           </a:p>
         </p:txBody>
@@ -4920,8 +5014,8 @@
         </p:nvSpPr>
         <p:spPr>
           <a:xfrm>
-            <a:off x="731520" y="1645920"/>
-            <a:ext cx="3413455" cy="3840480"/>
+            <a:off x="731520" y="1463040"/>
+            <a:ext cx="10728655" cy="4754880"/>
           </a:xfrm>
           <a:prstGeom prst="rect">
             <a:avLst/>
@@ -4965,8 +5059,8 @@
         </p:nvSpPr>
         <p:spPr>
           <a:xfrm>
-            <a:off x="914400" y="1828800"/>
-            <a:ext cx="3047695" cy="3474720"/>
+            <a:off x="1005840" y="1691640"/>
+            <a:ext cx="10180015" cy="4297680"/>
           </a:xfrm>
           <a:prstGeom prst="rect">
             <a:avLst/>
@@ -4980,380 +5074,107 @@
           <a:lstStyle/>
           <a:p>
             <a:pPr>
-              <a:defRPr sz="1800" b="1">
+              <a:spcAft>
+                <a:spcPts val="800"/>
+              </a:spcAft>
+              <a:defRPr sz="1900" b="1">
+                <a:solidFill>
+                  <a:srgbClr val="D4A843"/>
+                </a:solidFill>
+              </a:defRPr>
+            </a:pPr>
+            <a:r>
+              <a:t>🎯 Принципы честности и доверия (Против избитых штампов)</a:t>
+            </a:r>
+          </a:p>
+          <a:p>
+            <a:pPr>
+              <a:spcAft>
+                <a:spcPts val="1600"/>
+              </a:spcAft>
+              <a:defRPr sz="1300">
+                <a:solidFill>
+                  <a:srgbClr val="AAB9CD"/>
+                </a:solidFill>
+              </a:defRPr>
+            </a:pPr>
+            <a:r>
+              <a:t>«Мы не используем громкие обещания вроде "Профессия будущего" или "Гарантированное трудоустройство" — в большинстве случаев это обман. Программирование — это сложно, но мы стремимся максимально упростить сложное и предоставить настоящие навыки.»</a:t>
+            </a:r>
+          </a:p>
+          <a:p>
+            <a:pPr>
+              <a:spcAft>
+                <a:spcPts val="800"/>
+              </a:spcAft>
+              <a:defRPr sz="1600" b="1">
                 <a:solidFill>
                   <a:srgbClr val="FFFFFF"/>
                 </a:solidFill>
               </a:defRPr>
             </a:pPr>
             <a:r>
-              <a:t>Front-End Junior</a:t>
+              <a:t>Основные механизмы удержания и контроля:</a:t>
             </a:r>
           </a:p>
           <a:p>
             <a:pPr>
               <a:spcAft>
-                <a:spcPts val="600"/>
+                <a:spcPts val="400"/>
               </a:spcAft>
-              <a:defRPr sz="2000" b="1">
-                <a:solidFill>
-                  <a:srgbClr val="D4A843"/>
-                </a:solidFill>
-              </a:defRPr>
-            </a:pPr>
-            <a:r>
-              <a:t>23 000 ₸ / мес</a:t>
+              <a:defRPr sz="1300">
+                <a:solidFill>
+                  <a:srgbClr val="F5F7FA"/>
+                </a:solidFill>
+              </a:defRPr>
+            </a:pPr>
+            <a:r>
+              <a:t>• Геймификация и интерактив для удержания внимания детей.</a:t>
             </a:r>
           </a:p>
           <a:p>
             <a:pPr>
               <a:spcAft>
-                <a:spcPts val="1200"/>
+                <a:spcPts val="400"/>
               </a:spcAft>
-              <a:defRPr sz="1200">
-                <a:solidFill>
-                  <a:srgbClr val="1A8A8A"/>
-                </a:solidFill>
-              </a:defRPr>
-            </a:pPr>
-            <a:r>
-              <a:t>Длительность: 4 месяца</a:t>
-            </a:r>
-          </a:p>
-          <a:p>
-            <a:pPr>
               <a:defRPr sz="1300">
                 <a:solidFill>
-                  <a:srgbClr val="AAB9CD"/>
-                </a:solidFill>
-              </a:defRPr>
-            </a:pPr>
-            <a:r>
-              <a:t>Основы HTML, CSS, JavaScript, верстка современных сайтов и интерактивных интерфейсов.</a:t>
-            </a:r>
-          </a:p>
-        </p:txBody>
-      </p:sp>
-      <p:sp>
-        <p:nvSpPr>
-          <p:cNvPr id="6" name="Rectangle 5"/>
-          <p:cNvSpPr/>
-          <p:nvPr/>
-        </p:nvSpPr>
-        <p:spPr>
-          <a:xfrm>
-            <a:off x="4389120" y="1645920"/>
-            <a:ext cx="3413455" cy="3840480"/>
-          </a:xfrm>
-          <a:prstGeom prst="rect">
-            <a:avLst/>
-          </a:prstGeom>
-          <a:solidFill>
-            <a:srgbClr val="12233C"/>
-          </a:solidFill>
-          <a:ln w="12700">
-            <a:solidFill>
-              <a:srgbClr val="233C5F"/>
-            </a:solidFill>
-          </a:ln>
-        </p:spPr>
-        <p:style>
-          <a:lnRef idx="1">
-            <a:schemeClr val="accent1"/>
-          </a:lnRef>
-          <a:fillRef idx="3">
-            <a:schemeClr val="accent1"/>
-          </a:fillRef>
-          <a:effectRef idx="2">
-            <a:schemeClr val="accent1"/>
-          </a:effectRef>
-          <a:fontRef idx="minor">
-            <a:schemeClr val="lt1"/>
-          </a:fontRef>
-        </p:style>
-        <p:txBody>
-          <a:bodyPr rtlCol="0" anchor="ctr"/>
-          <a:lstStyle/>
-          <a:p>
-            <a:pPr algn="ctr"/>
-          </a:p>
-        </p:txBody>
-      </p:sp>
-      <p:sp>
-        <p:nvSpPr>
-          <p:cNvPr id="7" name="TextBox 6"/>
-          <p:cNvSpPr txBox="1"/>
-          <p:nvPr/>
-        </p:nvSpPr>
-        <p:spPr>
-          <a:xfrm>
-            <a:off x="4572000" y="1828800"/>
-            <a:ext cx="3047695" cy="3474720"/>
-          </a:xfrm>
-          <a:prstGeom prst="rect">
-            <a:avLst/>
-          </a:prstGeom>
-          <a:noFill/>
-        </p:spPr>
-        <p:txBody>
-          <a:bodyPr wrap="square">
-            <a:spAutoFit/>
-          </a:bodyPr>
-          <a:lstStyle/>
-          <a:p>
-            <a:pPr>
-              <a:defRPr sz="1800" b="1">
-                <a:solidFill>
-                  <a:srgbClr val="FFFFFF"/>
-                </a:solidFill>
-              </a:defRPr>
-            </a:pPr>
-            <a:r>
-              <a:t>UI/UX Дизайн</a:t>
+                  <a:srgbClr val="F5F7FA"/>
+                </a:solidFill>
+              </a:defRPr>
+            </a:pPr>
+            <a:r>
+              <a:t>• Ежемесячные отчеты родителям об успеваемости и прогрессе ребенка.</a:t>
             </a:r>
           </a:p>
           <a:p>
             <a:pPr>
               <a:spcAft>
-                <a:spcPts val="600"/>
+                <a:spcPts val="400"/>
               </a:spcAft>
-              <a:defRPr sz="2000" b="1">
-                <a:solidFill>
-                  <a:srgbClr val="D4A843"/>
-                </a:solidFill>
-              </a:defRPr>
-            </a:pPr>
-            <a:r>
-              <a:t>19 000 ₸ / мес</a:t>
+              <a:defRPr sz="1300">
+                <a:solidFill>
+                  <a:srgbClr val="F5F7FA"/>
+                </a:solidFill>
+              </a:defRPr>
+            </a:pPr>
+            <a:r>
+              <a:t>• Контроль всего процесса обучения.</a:t>
             </a:r>
           </a:p>
           <a:p>
             <a:pPr>
               <a:spcAft>
-                <a:spcPts val="1200"/>
+                <a:spcPts val="400"/>
               </a:spcAft>
-              <a:defRPr sz="1200">
-                <a:solidFill>
-                  <a:srgbClr val="1A8A8A"/>
-                </a:solidFill>
-              </a:defRPr>
-            </a:pPr>
-            <a:r>
-              <a:t>Длительность: 4 месяца</a:t>
-            </a:r>
-          </a:p>
-          <a:p>
-            <a:pPr>
               <a:defRPr sz="1300">
                 <a:solidFill>
-                  <a:srgbClr val="AAB9CD"/>
-                </a:solidFill>
-              </a:defRPr>
-            </a:pPr>
-            <a:r>
-              <a:t>Проектирование пользовательских интерфейсов, работа в Figma, проведение UX-исследований.</a:t>
-            </a:r>
-          </a:p>
-        </p:txBody>
-      </p:sp>
-      <p:sp>
-        <p:nvSpPr>
-          <p:cNvPr id="8" name="Rectangle 7"/>
-          <p:cNvSpPr/>
-          <p:nvPr/>
-        </p:nvSpPr>
-        <p:spPr>
-          <a:xfrm>
-            <a:off x="8046720" y="1645920"/>
-            <a:ext cx="3413455" cy="3840480"/>
-          </a:xfrm>
-          <a:prstGeom prst="rect">
-            <a:avLst/>
-          </a:prstGeom>
-          <a:solidFill>
-            <a:srgbClr val="12233C"/>
-          </a:solidFill>
-          <a:ln w="12700">
-            <a:solidFill>
-              <a:srgbClr val="233C5F"/>
-            </a:solidFill>
-          </a:ln>
-        </p:spPr>
-        <p:style>
-          <a:lnRef idx="1">
-            <a:schemeClr val="accent1"/>
-          </a:lnRef>
-          <a:fillRef idx="3">
-            <a:schemeClr val="accent1"/>
-          </a:fillRef>
-          <a:effectRef idx="2">
-            <a:schemeClr val="accent1"/>
-          </a:effectRef>
-          <a:fontRef idx="minor">
-            <a:schemeClr val="lt1"/>
-          </a:fontRef>
-        </p:style>
-        <p:txBody>
-          <a:bodyPr rtlCol="0" anchor="ctr"/>
-          <a:lstStyle/>
-          <a:p>
-            <a:pPr algn="ctr"/>
-          </a:p>
-        </p:txBody>
-      </p:sp>
-      <p:sp>
-        <p:nvSpPr>
-          <p:cNvPr id="9" name="TextBox 8"/>
-          <p:cNvSpPr txBox="1"/>
-          <p:nvPr/>
-        </p:nvSpPr>
-        <p:spPr>
-          <a:xfrm>
-            <a:off x="8229600" y="1828800"/>
-            <a:ext cx="3047695" cy="3474720"/>
-          </a:xfrm>
-          <a:prstGeom prst="rect">
-            <a:avLst/>
-          </a:prstGeom>
-          <a:noFill/>
-        </p:spPr>
-        <p:txBody>
-          <a:bodyPr wrap="square">
-            <a:spAutoFit/>
-          </a:bodyPr>
-          <a:lstStyle/>
-          <a:p>
-            <a:pPr>
-              <a:defRPr sz="1800" b="1">
-                <a:solidFill>
-                  <a:srgbClr val="FFFFFF"/>
-                </a:solidFill>
-              </a:defRPr>
-            </a:pPr>
-            <a:r>
-              <a:t>Основы Python</a:t>
-            </a:r>
-          </a:p>
-          <a:p>
-            <a:pPr>
-              <a:spcAft>
-                <a:spcPts val="600"/>
-              </a:spcAft>
-              <a:defRPr sz="2000" b="1">
-                <a:solidFill>
-                  <a:srgbClr val="D4A843"/>
-                </a:solidFill>
-              </a:defRPr>
-            </a:pPr>
-            <a:r>
-              <a:t>27 000 ₸ / мес</a:t>
-            </a:r>
-          </a:p>
-          <a:p>
-            <a:pPr>
-              <a:spcAft>
-                <a:spcPts val="1200"/>
-              </a:spcAft>
-              <a:defRPr sz="1200">
-                <a:solidFill>
-                  <a:srgbClr val="1A8A8A"/>
-                </a:solidFill>
-              </a:defRPr>
-            </a:pPr>
-            <a:r>
-              <a:t>Длительность: 5 месяцев</a:t>
-            </a:r>
-          </a:p>
-          <a:p>
-            <a:pPr>
-              <a:defRPr sz="1300">
-                <a:solidFill>
-                  <a:srgbClr val="AAB9CD"/>
-                </a:solidFill>
-              </a:defRPr>
-            </a:pPr>
-            <a:r>
-              <a:t>Базовое программирование, алгоритмы, работа с данными и создание консольных/веб-приложений.</a:t>
-            </a:r>
-          </a:p>
-        </p:txBody>
-      </p:sp>
-      <p:sp>
-        <p:nvSpPr>
-          <p:cNvPr id="10" name="Rectangle 9"/>
-          <p:cNvSpPr/>
-          <p:nvPr/>
-        </p:nvSpPr>
-        <p:spPr>
-          <a:xfrm>
-            <a:off x="731520" y="5623560"/>
-            <a:ext cx="10728655" cy="731520"/>
-          </a:xfrm>
-          <a:prstGeom prst="rect">
-            <a:avLst/>
-          </a:prstGeom>
-          <a:solidFill>
-            <a:srgbClr val="12233C"/>
-          </a:solidFill>
-          <a:ln w="12700">
-            <a:solidFill>
-              <a:srgbClr val="233C5F"/>
-            </a:solidFill>
-          </a:ln>
-        </p:spPr>
-        <p:style>
-          <a:lnRef idx="1">
-            <a:schemeClr val="accent1"/>
-          </a:lnRef>
-          <a:fillRef idx="3">
-            <a:schemeClr val="accent1"/>
-          </a:fillRef>
-          <a:effectRef idx="2">
-            <a:schemeClr val="accent1"/>
-          </a:effectRef>
-          <a:fontRef idx="minor">
-            <a:schemeClr val="lt1"/>
-          </a:fontRef>
-        </p:style>
-        <p:txBody>
-          <a:bodyPr rtlCol="0" anchor="ctr"/>
-          <a:lstStyle/>
-          <a:p>
-            <a:pPr algn="ctr"/>
-          </a:p>
-        </p:txBody>
-      </p:sp>
-      <p:sp>
-        <p:nvSpPr>
-          <p:cNvPr id="11" name="TextBox 10"/>
-          <p:cNvSpPr txBox="1"/>
-          <p:nvPr/>
-        </p:nvSpPr>
-        <p:spPr>
-          <a:xfrm>
-            <a:off x="914400" y="5715000"/>
-            <a:ext cx="10362895" cy="548640"/>
-          </a:xfrm>
-          <a:prstGeom prst="rect">
-            <a:avLst/>
-          </a:prstGeom>
-          <a:noFill/>
-        </p:spPr>
-        <p:txBody>
-          <a:bodyPr wrap="square">
-            <a:spAutoFit/>
-          </a:bodyPr>
-          <a:lstStyle/>
-          <a:p>
-            <a:pPr>
-              <a:defRPr sz="1400" b="1">
-                <a:solidFill>
-                  <a:srgbClr val="D4A843"/>
-                </a:solidFill>
-              </a:defRPr>
-            </a:pPr>
-            <a:r>
-              <a:t>💡 Перспектива развития: Индивидуальное наставничество и VIP-форматы с выходом на взрослую аудиторию.</a:t>
+                  <a:srgbClr val="F5F7FA"/>
+                </a:solidFill>
+              </a:defRPr>
+            </a:pPr>
+            <a:r>
+              <a:t>• Предоставление официального документа (сертификата) с проверкой подлинности по QR-коду.</a:t>
             </a:r>
           </a:p>
         </p:txBody>
@@ -5392,8 +5213,8 @@
         </p:nvSpPr>
         <p:spPr>
           <a:xfrm>
-            <a:off x="731520" y="457200"/>
-            <a:ext cx="10698480" cy="365760"/>
+            <a:off x="731520" y="365760"/>
+            <a:ext cx="10698480" cy="320040"/>
           </a:xfrm>
           <a:prstGeom prst="rect">
             <a:avLst/>
@@ -5411,7 +5232,6 @@
                 <a:solidFill>
                   <a:srgbClr val="D4A843"/>
                 </a:solidFill>
-                <a:latin typeface="Arial"/>
               </a:defRPr>
             </a:pPr>
             <a:r>
@@ -5428,8 +5248,8 @@
         </p:nvSpPr>
         <p:spPr>
           <a:xfrm>
-            <a:off x="731520" y="777240"/>
-            <a:ext cx="10698480" cy="731520"/>
+            <a:off x="731520" y="685800"/>
+            <a:ext cx="10698480" cy="685800"/>
           </a:xfrm>
           <a:prstGeom prst="rect">
             <a:avLst/>
@@ -5443,15 +5263,14 @@
           <a:lstStyle/>
           <a:p>
             <a:pPr>
-              <a:defRPr sz="2600" b="1">
+              <a:defRPr sz="2400" b="1">
                 <a:solidFill>
                   <a:srgbClr val="FFFFFF"/>
                 </a:solidFill>
-                <a:latin typeface="Arial"/>
-              </a:defRPr>
-            </a:pPr>
-            <a:r>
-              <a:t>Ключевые ресурсы и Ключевые действия</a:t>
+              </a:defRPr>
+            </a:pPr>
+            <a:r>
+              <a:t>5. Потоки дохода и Расчет выручки</a:t>
             </a:r>
           </a:p>
         </p:txBody>
@@ -5464,8 +5283,8 @@
         </p:nvSpPr>
         <p:spPr>
           <a:xfrm>
-            <a:off x="731520" y="1645920"/>
-            <a:ext cx="5212080" cy="4572000"/>
+            <a:off x="731520" y="1463040"/>
+            <a:ext cx="3413455" cy="3291840"/>
           </a:xfrm>
           <a:prstGeom prst="rect">
             <a:avLst/>
@@ -5509,8 +5328,8 @@
         </p:nvSpPr>
         <p:spPr>
           <a:xfrm>
-            <a:off x="1005840" y="1920240"/>
-            <a:ext cx="4663440" cy="4023360"/>
+            <a:off x="914400" y="1645920"/>
+            <a:ext cx="3047695" cy="2926080"/>
           </a:xfrm>
           <a:prstGeom prst="rect">
             <a:avLst/>
@@ -5524,8 +5343,20 @@
           <a:lstStyle/>
           <a:p>
             <a:pPr>
+              <a:defRPr sz="1800" b="1">
+                <a:solidFill>
+                  <a:srgbClr val="FFFFFF"/>
+                </a:solidFill>
+              </a:defRPr>
+            </a:pPr>
+            <a:r>
+              <a:t>Frontend Junior</a:t>
+            </a:r>
+          </a:p>
+          <a:p>
+            <a:pPr>
               <a:spcAft>
-                <a:spcPts val="1400"/>
+                <a:spcPts val="400"/>
               </a:spcAft>
               <a:defRPr sz="2000" b="1">
                 <a:solidFill>
@@ -5534,19 +5365,7 @@
               </a:defRPr>
             </a:pPr>
             <a:r>
-              <a:t>🧩 Ключевые ресурсы</a:t>
-            </a:r>
-          </a:p>
-          <a:p>
-            <a:pPr>
-              <a:defRPr sz="1500" b="1">
-                <a:solidFill>
-                  <a:srgbClr val="FFFFFF"/>
-                </a:solidFill>
-              </a:defRPr>
-            </a:pPr>
-            <a:r>
-              <a:t>• Команда проекта</a:t>
+              <a:t>23 000 ₸ / мес</a:t>
             </a:r>
           </a:p>
           <a:p>
@@ -5554,68 +5373,30 @@
               <a:spcAft>
                 <a:spcPts val="1000"/>
               </a:spcAft>
-              <a:defRPr sz="1300">
-                <a:solidFill>
-                  <a:srgbClr val="AAB9CD"/>
-                </a:solidFill>
-              </a:defRPr>
-            </a:pPr>
-            <a:r>
-              <a:t>3 куратора-преподавателя (ведут по 4 группы каждый) + 1 администратор.</a:t>
-            </a:r>
-          </a:p>
-          <a:p>
-            <a:pPr>
-              <a:defRPr sz="1500" b="1">
-                <a:solidFill>
-                  <a:srgbClr val="FFFFFF"/>
-                </a:solidFill>
-              </a:defRPr>
-            </a:pPr>
-            <a:r>
-              <a:t>• Техническая база</a:t>
-            </a:r>
-          </a:p>
-          <a:p>
-            <a:pPr>
-              <a:spcAft>
-                <a:spcPts val="1000"/>
-              </a:spcAft>
-              <a:defRPr sz="1300">
-                <a:solidFill>
-                  <a:srgbClr val="AAB9CD"/>
-                </a:solidFill>
-              </a:defRPr>
-            </a:pPr>
-            <a:r>
-              <a:t>Официальный сайт, надежный хостинг и интерактивное веб-приложение.</a:t>
-            </a:r>
-          </a:p>
-          <a:p>
-            <a:pPr>
-              <a:defRPr sz="1500" b="1">
-                <a:solidFill>
-                  <a:srgbClr val="FFFFFF"/>
-                </a:solidFill>
-              </a:defRPr>
-            </a:pPr>
-            <a:r>
-              <a:t>• Методическая база</a:t>
-            </a:r>
-          </a:p>
-          <a:p>
-            <a:pPr>
-              <a:spcAft>
-                <a:spcPts val="1000"/>
-              </a:spcAft>
-              <a:defRPr sz="1300">
-                <a:solidFill>
-                  <a:srgbClr val="AAB9CD"/>
-                </a:solidFill>
-              </a:defRPr>
-            </a:pPr>
-            <a:r>
-              <a:t>Уникальные авторские учебные программы с подходом 70% практики / 30% теории.</a:t>
+              <a:defRPr sz="1200">
+                <a:solidFill>
+                  <a:srgbClr val="1A8A8A"/>
+                </a:solidFill>
+              </a:defRPr>
+            </a:pPr>
+            <a:r>
+              <a:t>4 месяца обучения</a:t>
+            </a:r>
+          </a:p>
+          <a:p>
+            <a:pPr>
+              <a:defRPr sz="1200">
+                <a:solidFill>
+                  <a:srgbClr val="F5F7FA"/>
+                </a:solidFill>
+              </a:defRPr>
+            </a:pPr>
+            <a:r>
+              <a:t>Расчет:</a:t>
+            </a:r>
+            <a:br/>
+            <a:r>
+              <a:t>23 000 ₸ × 12 чел × 4 гр - 10% = 993 600 ₸ / мес</a:t>
             </a:r>
           </a:p>
         </p:txBody>
@@ -5628,8 +5409,8 @@
         </p:nvSpPr>
         <p:spPr>
           <a:xfrm>
-            <a:off x="6248095" y="1645920"/>
-            <a:ext cx="5212080" cy="4572000"/>
+            <a:off x="4389120" y="1463040"/>
+            <a:ext cx="3413455" cy="3291840"/>
           </a:xfrm>
           <a:prstGeom prst="rect">
             <a:avLst/>
@@ -5673,8 +5454,8 @@
         </p:nvSpPr>
         <p:spPr>
           <a:xfrm>
-            <a:off x="6522415" y="1920240"/>
-            <a:ext cx="4663440" cy="4023360"/>
+            <a:off x="4572000" y="1645920"/>
+            <a:ext cx="3047695" cy="2926080"/>
           </a:xfrm>
           <a:prstGeom prst="rect">
             <a:avLst/>
@@ -5688,29 +5469,29 @@
           <a:lstStyle/>
           <a:p>
             <a:pPr>
+              <a:defRPr sz="1800" b="1">
+                <a:solidFill>
+                  <a:srgbClr val="FFFFFF"/>
+                </a:solidFill>
+              </a:defRPr>
+            </a:pPr>
+            <a:r>
+              <a:t>UI/UX Дизайн</a:t>
+            </a:r>
+          </a:p>
+          <a:p>
+            <a:pPr>
               <a:spcAft>
-                <a:spcPts val="1400"/>
+                <a:spcPts val="400"/>
               </a:spcAft>
               <a:defRPr sz="2000" b="1">
                 <a:solidFill>
-                  <a:srgbClr val="1A8A8A"/>
-                </a:solidFill>
-              </a:defRPr>
-            </a:pPr>
-            <a:r>
-              <a:t>⚙️ Ключевые действия</a:t>
-            </a:r>
-          </a:p>
-          <a:p>
-            <a:pPr>
-              <a:defRPr sz="1500" b="1">
-                <a:solidFill>
-                  <a:srgbClr val="FFFFFF"/>
-                </a:solidFill>
-              </a:defRPr>
-            </a:pPr>
-            <a:r>
-              <a:t>• Учебный процесс</a:t>
+                  <a:srgbClr val="D4A843"/>
+                </a:solidFill>
+              </a:defRPr>
+            </a:pPr>
+            <a:r>
+              <a:t>19 000 ₸ / мес</a:t>
             </a:r>
           </a:p>
           <a:p>
@@ -5718,26 +5499,125 @@
               <a:spcAft>
                 <a:spcPts val="1000"/>
               </a:spcAft>
-              <a:defRPr sz="1300">
-                <a:solidFill>
-                  <a:srgbClr val="AAB9CD"/>
-                </a:solidFill>
-              </a:defRPr>
-            </a:pPr>
-            <a:r>
-              <a:t>Проведение интерактивных онлайн-занятий и подробная проверка домашних заданий.</a:t>
-            </a:r>
-          </a:p>
-          <a:p>
-            <a:pPr>
-              <a:defRPr sz="1500" b="1">
+              <a:defRPr sz="1200">
+                <a:solidFill>
+                  <a:srgbClr val="1A8A8A"/>
+                </a:solidFill>
+              </a:defRPr>
+            </a:pPr>
+            <a:r>
+              <a:t>4 месяца обучения</a:t>
+            </a:r>
+          </a:p>
+          <a:p>
+            <a:pPr>
+              <a:defRPr sz="1200">
+                <a:solidFill>
+                  <a:srgbClr val="F5F7FA"/>
+                </a:solidFill>
+              </a:defRPr>
+            </a:pPr>
+            <a:r>
+              <a:t>Расчет:</a:t>
+            </a:r>
+            <a:br/>
+            <a:r>
+              <a:t>19 000 ₸ × 12 чел × 4 гр - 10% = 820 800 ₸ / мес</a:t>
+            </a:r>
+          </a:p>
+        </p:txBody>
+      </p:sp>
+      <p:sp>
+        <p:nvSpPr>
+          <p:cNvPr id="8" name="Rectangle 7"/>
+          <p:cNvSpPr/>
+          <p:nvPr/>
+        </p:nvSpPr>
+        <p:spPr>
+          <a:xfrm>
+            <a:off x="8046720" y="1463040"/>
+            <a:ext cx="3413455" cy="3291840"/>
+          </a:xfrm>
+          <a:prstGeom prst="rect">
+            <a:avLst/>
+          </a:prstGeom>
+          <a:solidFill>
+            <a:srgbClr val="12233C"/>
+          </a:solidFill>
+          <a:ln w="12700">
+            <a:solidFill>
+              <a:srgbClr val="233C5F"/>
+            </a:solidFill>
+          </a:ln>
+        </p:spPr>
+        <p:style>
+          <a:lnRef idx="1">
+            <a:schemeClr val="accent1"/>
+          </a:lnRef>
+          <a:fillRef idx="3">
+            <a:schemeClr val="accent1"/>
+          </a:fillRef>
+          <a:effectRef idx="2">
+            <a:schemeClr val="accent1"/>
+          </a:effectRef>
+          <a:fontRef idx="minor">
+            <a:schemeClr val="lt1"/>
+          </a:fontRef>
+        </p:style>
+        <p:txBody>
+          <a:bodyPr rtlCol="0" anchor="ctr"/>
+          <a:lstStyle/>
+          <a:p>
+            <a:pPr algn="ctr"/>
+          </a:p>
+        </p:txBody>
+      </p:sp>
+      <p:sp>
+        <p:nvSpPr>
+          <p:cNvPr id="9" name="TextBox 8"/>
+          <p:cNvSpPr txBox="1"/>
+          <p:nvPr/>
+        </p:nvSpPr>
+        <p:spPr>
+          <a:xfrm>
+            <a:off x="8229600" y="1645920"/>
+            <a:ext cx="3047695" cy="2926080"/>
+          </a:xfrm>
+          <a:prstGeom prst="rect">
+            <a:avLst/>
+          </a:prstGeom>
+          <a:noFill/>
+        </p:spPr>
+        <p:txBody>
+          <a:bodyPr wrap="square">
+            <a:spAutoFit/>
+          </a:bodyPr>
+          <a:lstStyle/>
+          <a:p>
+            <a:pPr>
+              <a:defRPr sz="1800" b="1">
                 <a:solidFill>
                   <a:srgbClr val="FFFFFF"/>
                 </a:solidFill>
               </a:defRPr>
             </a:pPr>
             <a:r>
-              <a:t>• Техническое сопровождение</a:t>
+              <a:t>Основы Python</a:t>
+            </a:r>
+          </a:p>
+          <a:p>
+            <a:pPr>
+              <a:spcAft>
+                <a:spcPts val="400"/>
+              </a:spcAft>
+              <a:defRPr sz="2000" b="1">
+                <a:solidFill>
+                  <a:srgbClr val="D4A843"/>
+                </a:solidFill>
+              </a:defRPr>
+            </a:pPr>
+            <a:r>
+              <a:t>27 000 ₸ / мес</a:t>
             </a:r>
           </a:p>
           <a:p>
@@ -5745,41 +5625,126 @@
               <a:spcAft>
                 <a:spcPts val="1000"/>
               </a:spcAft>
-              <a:defRPr sz="1300">
-                <a:solidFill>
-                  <a:srgbClr val="AAB9CD"/>
-                </a:solidFill>
-              </a:defRPr>
-            </a:pPr>
-            <a:r>
-              <a:t>Бесперебойная поддержка платформы и веб-сервисов.</a:t>
-            </a:r>
-          </a:p>
-          <a:p>
-            <a:pPr>
-              <a:defRPr sz="1500" b="1">
-                <a:solidFill>
-                  <a:srgbClr val="FFFFFF"/>
-                </a:solidFill>
-              </a:defRPr>
-            </a:pPr>
-            <a:r>
-              <a:t>• Администрирование</a:t>
-            </a:r>
-          </a:p>
-          <a:p>
-            <a:pPr>
-              <a:spcAft>
-                <a:spcPts val="1000"/>
-              </a:spcAft>
-              <a:defRPr sz="1300">
-                <a:solidFill>
-                  <a:srgbClr val="AAB9CD"/>
-                </a:solidFill>
-              </a:defRPr>
-            </a:pPr>
-            <a:r>
-              <a:t>Контроль оплат, ведение базы учеников и регулярная подготовка отчетов для родителей.</a:t>
+              <a:defRPr sz="1200">
+                <a:solidFill>
+                  <a:srgbClr val="1A8A8A"/>
+                </a:solidFill>
+              </a:defRPr>
+            </a:pPr>
+            <a:r>
+              <a:t>5 месяцев обучения</a:t>
+            </a:r>
+          </a:p>
+          <a:p>
+            <a:pPr>
+              <a:defRPr sz="1200">
+                <a:solidFill>
+                  <a:srgbClr val="F5F7FA"/>
+                </a:solidFill>
+              </a:defRPr>
+            </a:pPr>
+            <a:r>
+              <a:t>Расчет:</a:t>
+            </a:r>
+            <a:br/>
+            <a:r>
+              <a:t>27 000 ₸ × 12 чел × 4 гр - 10% = 1 166 400 ₸ / мес</a:t>
+            </a:r>
+          </a:p>
+        </p:txBody>
+      </p:sp>
+      <p:sp>
+        <p:nvSpPr>
+          <p:cNvPr id="10" name="Rectangle 9"/>
+          <p:cNvSpPr/>
+          <p:nvPr/>
+        </p:nvSpPr>
+        <p:spPr>
+          <a:xfrm>
+            <a:off x="731520" y="4892040"/>
+            <a:ext cx="10728655" cy="1371600"/>
+          </a:xfrm>
+          <a:prstGeom prst="rect">
+            <a:avLst/>
+          </a:prstGeom>
+          <a:solidFill>
+            <a:srgbClr val="12233C"/>
+          </a:solidFill>
+          <a:ln w="12700">
+            <a:solidFill>
+              <a:srgbClr val="233C5F"/>
+            </a:solidFill>
+          </a:ln>
+        </p:spPr>
+        <p:style>
+          <a:lnRef idx="1">
+            <a:schemeClr val="accent1"/>
+          </a:lnRef>
+          <a:fillRef idx="3">
+            <a:schemeClr val="accent1"/>
+          </a:fillRef>
+          <a:effectRef idx="2">
+            <a:schemeClr val="accent1"/>
+          </a:effectRef>
+          <a:fontRef idx="minor">
+            <a:schemeClr val="lt1"/>
+          </a:fontRef>
+        </p:style>
+        <p:txBody>
+          <a:bodyPr rtlCol="0" anchor="ctr"/>
+          <a:lstStyle/>
+          <a:p>
+            <a:pPr algn="ctr"/>
+          </a:p>
+        </p:txBody>
+      </p:sp>
+      <p:sp>
+        <p:nvSpPr>
+          <p:cNvPr id="11" name="TextBox 10"/>
+          <p:cNvSpPr txBox="1"/>
+          <p:nvPr/>
+        </p:nvSpPr>
+        <p:spPr>
+          <a:xfrm>
+            <a:off x="1005840" y="4983480"/>
+            <a:ext cx="10180015" cy="1188720"/>
+          </a:xfrm>
+          <a:prstGeom prst="rect">
+            <a:avLst/>
+          </a:prstGeom>
+          <a:noFill/>
+        </p:spPr>
+        <p:txBody>
+          <a:bodyPr wrap="square">
+            <a:spAutoFit/>
+          </a:bodyPr>
+          <a:lstStyle/>
+          <a:p>
+            <a:pPr>
+              <a:defRPr sz="2000" b="1">
+                <a:solidFill>
+                  <a:srgbClr val="D4A843"/>
+                </a:solidFill>
+              </a:defRPr>
+            </a:pPr>
+            <a:r>
+              <a:t>💰 Итого суммарный доход в месяц: 2 980 800 ₸</a:t>
+            </a:r>
+          </a:p>
+          <a:p>
+            <a:pPr>
+              <a:defRPr sz="1200">
+                <a:solidFill>
+                  <a:srgbClr val="F5F7FA"/>
+                </a:solidFill>
+              </a:defRPr>
+            </a:pPr>
+            <a:r>
+              <a:t>• Скидки: 10% при разовой оплате всего курса | 20% реферальный промокод выпускника для знакомых на 1-й месяц.</a:t>
+            </a:r>
+            <a:br/>
+            <a:r>
+              <a:t>• Перспектива: Индивидуальное наставничество при масштабировании на взрослую аудиторию.</a:t>
             </a:r>
           </a:p>
         </p:txBody>
@@ -5818,8 +5783,8 @@
         </p:nvSpPr>
         <p:spPr>
           <a:xfrm>
-            <a:off x="731520" y="457200"/>
-            <a:ext cx="10698480" cy="365760"/>
+            <a:off x="731520" y="365760"/>
+            <a:ext cx="10698480" cy="320040"/>
           </a:xfrm>
           <a:prstGeom prst="rect">
             <a:avLst/>
@@ -5837,7 +5802,6 @@
                 <a:solidFill>
                   <a:srgbClr val="D4A843"/>
                 </a:solidFill>
-                <a:latin typeface="Arial"/>
               </a:defRPr>
             </a:pPr>
             <a:r>
@@ -5854,8 +5818,8 @@
         </p:nvSpPr>
         <p:spPr>
           <a:xfrm>
-            <a:off x="731520" y="777240"/>
-            <a:ext cx="10698480" cy="731520"/>
+            <a:off x="731520" y="685800"/>
+            <a:ext cx="10698480" cy="685800"/>
           </a:xfrm>
           <a:prstGeom prst="rect">
             <a:avLst/>
@@ -5869,15 +5833,14 @@
           <a:lstStyle/>
           <a:p>
             <a:pPr>
-              <a:defRPr sz="2600" b="1">
+              <a:defRPr sz="2400" b="1">
                 <a:solidFill>
                   <a:srgbClr val="FFFFFF"/>
                 </a:solidFill>
-                <a:latin typeface="Arial"/>
-              </a:defRPr>
-            </a:pPr>
-            <a:r>
-              <a:t>Ключевые партнёры</a:t>
+              </a:defRPr>
+            </a:pPr>
+            <a:r>
+              <a:t>6. Ключевые ресурсы &amp; 7. Ключевые действия</a:t>
             </a:r>
           </a:p>
         </p:txBody>
@@ -5890,8 +5853,8 @@
         </p:nvSpPr>
         <p:spPr>
           <a:xfrm>
-            <a:off x="731520" y="1645920"/>
-            <a:ext cx="5212080" cy="2103120"/>
+            <a:off x="731520" y="1463040"/>
+            <a:ext cx="5212080" cy="4754880"/>
           </a:xfrm>
           <a:prstGeom prst="rect">
             <a:avLst/>
@@ -5935,8 +5898,8 @@
         </p:nvSpPr>
         <p:spPr>
           <a:xfrm>
-            <a:off x="1005840" y="1828800"/>
-            <a:ext cx="4663440" cy="1737360"/>
+            <a:off x="1005840" y="1691640"/>
+            <a:ext cx="4663440" cy="4297680"/>
           </a:xfrm>
           <a:prstGeom prst="rect">
             <a:avLst/>
@@ -5950,41 +5913,77 @@
           <a:lstStyle/>
           <a:p>
             <a:pPr>
-              <a:defRPr sz="1500" b="1">
+              <a:spcAft>
+                <a:spcPts val="1000"/>
+              </a:spcAft>
+              <a:defRPr sz="1900" b="1">
                 <a:solidFill>
                   <a:srgbClr val="D4A843"/>
                 </a:solidFill>
               </a:defRPr>
             </a:pPr>
             <a:r>
-              <a:t>💳 Финансы &amp; Платежи</a:t>
+              <a:t>🧩 Ключевые ресурсы</a:t>
             </a:r>
           </a:p>
           <a:p>
             <a:pPr>
               <a:spcAft>
-                <a:spcPts val="400"/>
+                <a:spcPts val="800"/>
               </a:spcAft>
-              <a:defRPr sz="1800" b="1">
-                <a:solidFill>
-                  <a:srgbClr val="FFFFFF"/>
-                </a:solidFill>
-              </a:defRPr>
-            </a:pPr>
-            <a:r>
-              <a:t>Kaspi Bank</a:t>
-            </a:r>
-          </a:p>
-          <a:p>
-            <a:pPr>
-              <a:defRPr sz="1300">
-                <a:solidFill>
-                  <a:srgbClr val="AAB9CD"/>
-                </a:solidFill>
-              </a:defRPr>
-            </a:pPr>
-            <a:r>
-              <a:t>Прием онлайн-платежей, удобный расчет для родителей через Kaspi Pay/QR.</a:t>
+              <a:defRPr sz="1200">
+                <a:solidFill>
+                  <a:srgbClr val="F5F7FA"/>
+                </a:solidFill>
+              </a:defRPr>
+            </a:pPr>
+            <a:r>
+              <a:t>• Команда: 3 куратора-преподавателя (ведут по 4 группы) + 1 администратор.</a:t>
+            </a:r>
+          </a:p>
+          <a:p>
+            <a:pPr>
+              <a:spcAft>
+                <a:spcPts val="800"/>
+              </a:spcAft>
+              <a:defRPr sz="1200">
+                <a:solidFill>
+                  <a:srgbClr val="F5F7FA"/>
+                </a:solidFill>
+              </a:defRPr>
+            </a:pPr>
+            <a:r>
+              <a:t>• Техническая база: Сайт, хостинг, веб-приложение, Телеграм бот.</a:t>
+            </a:r>
+          </a:p>
+          <a:p>
+            <a:pPr>
+              <a:spcAft>
+                <a:spcPts val="800"/>
+              </a:spcAft>
+              <a:defRPr sz="1200">
+                <a:solidFill>
+                  <a:srgbClr val="F5F7FA"/>
+                </a:solidFill>
+              </a:defRPr>
+            </a:pPr>
+            <a:r>
+              <a:t>• Методическая база: Уникальные учебные программы (70% практика / 30% теория), хакатоны и мероприятия.</a:t>
+            </a:r>
+          </a:p>
+          <a:p>
+            <a:pPr>
+              <a:spcAft>
+                <a:spcPts val="800"/>
+              </a:spcAft>
+              <a:defRPr sz="1200">
+                <a:solidFill>
+                  <a:srgbClr val="F5F7FA"/>
+                </a:solidFill>
+              </a:defRPr>
+            </a:pPr>
+            <a:r>
+              <a:t>• При масштабировании: Найм преподавателей и SMM-специалистов (на старте реклама ведется администратором).</a:t>
             </a:r>
           </a:p>
         </p:txBody>
@@ -5997,8 +5996,8 @@
         </p:nvSpPr>
         <p:spPr>
           <a:xfrm>
-            <a:off x="6248095" y="1645920"/>
-            <a:ext cx="5212080" cy="2103120"/>
+            <a:off x="6248095" y="1463040"/>
+            <a:ext cx="5212080" cy="4754880"/>
           </a:xfrm>
           <a:prstGeom prst="rect">
             <a:avLst/>
@@ -6042,8 +6041,8 @@
         </p:nvSpPr>
         <p:spPr>
           <a:xfrm>
-            <a:off x="6522415" y="1828800"/>
-            <a:ext cx="4663440" cy="1737360"/>
+            <a:off x="6522415" y="1691640"/>
+            <a:ext cx="4663440" cy="4297680"/>
           </a:xfrm>
           <a:prstGeom prst="rect">
             <a:avLst/>
@@ -6057,255 +6056,107 @@
           <a:lstStyle/>
           <a:p>
             <a:pPr>
-              <a:defRPr sz="1500" b="1">
-                <a:solidFill>
-                  <a:srgbClr val="D4A843"/>
-                </a:solidFill>
-              </a:defRPr>
-            </a:pPr>
-            <a:r>
-              <a:t>🖥️ Инфраструктура</a:t>
-            </a:r>
-          </a:p>
-          <a:p>
-            <a:pPr>
               <a:spcAft>
-                <a:spcPts val="400"/>
+                <a:spcPts val="1000"/>
               </a:spcAft>
-              <a:defRPr sz="1800" b="1">
-                <a:solidFill>
-                  <a:srgbClr val="FFFFFF"/>
-                </a:solidFill>
-              </a:defRPr>
-            </a:pPr>
-            <a:r>
-              <a:t>Хостинг-провайдеры</a:t>
-            </a:r>
-          </a:p>
-          <a:p>
-            <a:pPr>
-              <a:defRPr sz="1300">
-                <a:solidFill>
-                  <a:srgbClr val="AAB9CD"/>
-                </a:solidFill>
-              </a:defRPr>
-            </a:pPr>
-            <a:r>
-              <a:t>Обеспечение высокой доступности, быстрой загрузки и надежности веб-платформы.</a:t>
-            </a:r>
-          </a:p>
-        </p:txBody>
-      </p:sp>
-      <p:sp>
-        <p:nvSpPr>
-          <p:cNvPr id="8" name="Rectangle 7"/>
-          <p:cNvSpPr/>
-          <p:nvPr/>
-        </p:nvSpPr>
-        <p:spPr>
-          <a:xfrm>
-            <a:off x="731520" y="4023360"/>
-            <a:ext cx="5212080" cy="2103120"/>
-          </a:xfrm>
-          <a:prstGeom prst="rect">
-            <a:avLst/>
-          </a:prstGeom>
-          <a:solidFill>
-            <a:srgbClr val="12233C"/>
-          </a:solidFill>
-          <a:ln w="12700">
-            <a:solidFill>
-              <a:srgbClr val="233C5F"/>
-            </a:solidFill>
-          </a:ln>
-        </p:spPr>
-        <p:style>
-          <a:lnRef idx="1">
-            <a:schemeClr val="accent1"/>
-          </a:lnRef>
-          <a:fillRef idx="3">
-            <a:schemeClr val="accent1"/>
-          </a:fillRef>
-          <a:effectRef idx="2">
-            <a:schemeClr val="accent1"/>
-          </a:effectRef>
-          <a:fontRef idx="minor">
-            <a:schemeClr val="lt1"/>
-          </a:fontRef>
-        </p:style>
-        <p:txBody>
-          <a:bodyPr rtlCol="0" anchor="ctr"/>
-          <a:lstStyle/>
-          <a:p>
-            <a:pPr algn="ctr"/>
-          </a:p>
-        </p:txBody>
-      </p:sp>
-      <p:sp>
-        <p:nvSpPr>
-          <p:cNvPr id="9" name="TextBox 8"/>
-          <p:cNvSpPr txBox="1"/>
-          <p:nvPr/>
-        </p:nvSpPr>
-        <p:spPr>
-          <a:xfrm>
-            <a:off x="1005840" y="4206240"/>
-            <a:ext cx="4663440" cy="1737360"/>
-          </a:xfrm>
-          <a:prstGeom prst="rect">
-            <a:avLst/>
-          </a:prstGeom>
-          <a:noFill/>
-        </p:spPr>
-        <p:txBody>
-          <a:bodyPr wrap="square">
-            <a:spAutoFit/>
-          </a:bodyPr>
-          <a:lstStyle/>
-          <a:p>
-            <a:pPr>
-              <a:defRPr sz="1500" b="1">
-                <a:solidFill>
-                  <a:srgbClr val="D4A843"/>
-                </a:solidFill>
-              </a:defRPr>
-            </a:pPr>
-            <a:r>
-              <a:t>🎓 Образование</a:t>
+              <a:defRPr sz="1900" b="1">
+                <a:solidFill>
+                  <a:srgbClr val="1A8A8A"/>
+                </a:solidFill>
+              </a:defRPr>
+            </a:pPr>
+            <a:r>
+              <a:t>⚙️ Ключевые действия</a:t>
             </a:r>
           </a:p>
           <a:p>
             <a:pPr>
               <a:spcAft>
-                <a:spcPts val="400"/>
+                <a:spcPts val="600"/>
               </a:spcAft>
-              <a:defRPr sz="1800" b="1">
-                <a:solidFill>
-                  <a:srgbClr val="FFFFFF"/>
-                </a:solidFill>
-              </a:defRPr>
-            </a:pPr>
-            <a:r>
-              <a:t>Школы и вузы РК</a:t>
-            </a:r>
-          </a:p>
-          <a:p>
-            <a:pPr>
-              <a:defRPr sz="1300">
-                <a:solidFill>
-                  <a:srgbClr val="AAB9CD"/>
-                </a:solidFill>
-              </a:defRPr>
-            </a:pPr>
-            <a:r>
-              <a:t>Информационное сотрудничество, привлечение школьников и проведение совместных мероприятий.</a:t>
-            </a:r>
-          </a:p>
-        </p:txBody>
-      </p:sp>
-      <p:sp>
-        <p:nvSpPr>
-          <p:cNvPr id="10" name="Rectangle 9"/>
-          <p:cNvSpPr/>
-          <p:nvPr/>
-        </p:nvSpPr>
-        <p:spPr>
-          <a:xfrm>
-            <a:off x="6248095" y="4023360"/>
-            <a:ext cx="5212080" cy="2103120"/>
-          </a:xfrm>
-          <a:prstGeom prst="rect">
-            <a:avLst/>
-          </a:prstGeom>
-          <a:solidFill>
-            <a:srgbClr val="12233C"/>
-          </a:solidFill>
-          <a:ln w="12700">
-            <a:solidFill>
-              <a:srgbClr val="233C5F"/>
-            </a:solidFill>
-          </a:ln>
-        </p:spPr>
-        <p:style>
-          <a:lnRef idx="1">
-            <a:schemeClr val="accent1"/>
-          </a:lnRef>
-          <a:fillRef idx="3">
-            <a:schemeClr val="accent1"/>
-          </a:fillRef>
-          <a:effectRef idx="2">
-            <a:schemeClr val="accent1"/>
-          </a:effectRef>
-          <a:fontRef idx="minor">
-            <a:schemeClr val="lt1"/>
-          </a:fontRef>
-        </p:style>
-        <p:txBody>
-          <a:bodyPr rtlCol="0" anchor="ctr"/>
-          <a:lstStyle/>
-          <a:p>
-            <a:pPr algn="ctr"/>
-          </a:p>
-        </p:txBody>
-      </p:sp>
-      <p:sp>
-        <p:nvSpPr>
-          <p:cNvPr id="11" name="TextBox 10"/>
-          <p:cNvSpPr txBox="1"/>
-          <p:nvPr/>
-        </p:nvSpPr>
-        <p:spPr>
-          <a:xfrm>
-            <a:off x="6522415" y="4206240"/>
-            <a:ext cx="4663440" cy="1737360"/>
-          </a:xfrm>
-          <a:prstGeom prst="rect">
-            <a:avLst/>
-          </a:prstGeom>
-          <a:noFill/>
-        </p:spPr>
-        <p:txBody>
-          <a:bodyPr wrap="square">
-            <a:spAutoFit/>
-          </a:bodyPr>
-          <a:lstStyle/>
-          <a:p>
-            <a:pPr>
-              <a:defRPr sz="1500" b="1">
-                <a:solidFill>
-                  <a:srgbClr val="D4A843"/>
-                </a:solidFill>
-              </a:defRPr>
-            </a:pPr>
-            <a:r>
-              <a:t>📣 Маркетинг</a:t>
+              <a:defRPr sz="1200">
+                <a:solidFill>
+                  <a:srgbClr val="F5F7FA"/>
+                </a:solidFill>
+              </a:defRPr>
+            </a:pPr>
+            <a:r>
+              <a:t>• Заработок стартового капитала на фриланс-проектах группой.</a:t>
             </a:r>
           </a:p>
           <a:p>
             <a:pPr>
               <a:spcAft>
-                <a:spcPts val="400"/>
+                <a:spcPts val="600"/>
               </a:spcAft>
-              <a:defRPr sz="1800" b="1">
-                <a:solidFill>
-                  <a:srgbClr val="FFFFFF"/>
-                </a:solidFill>
-              </a:defRPr>
-            </a:pPr>
-            <a:r>
-              <a:t>Рекламные площадки</a:t>
-            </a:r>
-          </a:p>
-          <a:p>
-            <a:pPr>
-              <a:defRPr sz="1300">
-                <a:solidFill>
-                  <a:srgbClr val="AAB9CD"/>
-                </a:solidFill>
-              </a:defRPr>
-            </a:pPr>
-            <a:r>
-              <a:t>Эффективное продвижение, таргетированная реклама и работа локальных промоутеров.</a:t>
+              <a:defRPr sz="1200">
+                <a:solidFill>
+                  <a:srgbClr val="F5F7FA"/>
+                </a:solidFill>
+              </a:defRPr>
+            </a:pPr>
+            <a:r>
+              <a:t>• Создание полной программы обучения и загрузка на платформу.</a:t>
+            </a:r>
+          </a:p>
+          <a:p>
+            <a:pPr>
+              <a:spcAft>
+                <a:spcPts val="600"/>
+              </a:spcAft>
+              <a:defRPr sz="1200">
+                <a:solidFill>
+                  <a:srgbClr val="F5F7FA"/>
+                </a:solidFill>
+              </a:defRPr>
+            </a:pPr>
+            <a:r>
+              <a:t>• Регистрация проекта как ИП по упрощёнке.</a:t>
+            </a:r>
+          </a:p>
+          <a:p>
+            <a:pPr>
+              <a:spcAft>
+                <a:spcPts val="600"/>
+              </a:spcAft>
+              <a:defRPr sz="1200">
+                <a:solidFill>
+                  <a:srgbClr val="F5F7FA"/>
+                </a:solidFill>
+              </a:defRPr>
+            </a:pPr>
+            <a:r>
+              <a:t>• Проведение маркетинговой кампании.</a:t>
+            </a:r>
+          </a:p>
+          <a:p>
+            <a:pPr>
+              <a:spcAft>
+                <a:spcPts val="600"/>
+              </a:spcAft>
+              <a:defRPr sz="1200">
+                <a:solidFill>
+                  <a:srgbClr val="F5F7FA"/>
+                </a:solidFill>
+              </a:defRPr>
+            </a:pPr>
+            <a:r>
+              <a:t>• Административная работа, контроль оплат и отчеты родителям.</a:t>
+            </a:r>
+          </a:p>
+          <a:p>
+            <a:pPr>
+              <a:spcAft>
+                <a:spcPts val="600"/>
+              </a:spcAft>
+              <a:defRPr sz="1200">
+                <a:solidFill>
+                  <a:srgbClr val="F5F7FA"/>
+                </a:solidFill>
+              </a:defRPr>
+            </a:pPr>
+            <a:r>
+              <a:t>• Организация соревнований и хакатонов для ровесников.</a:t>
             </a:r>
           </a:p>
         </p:txBody>
@@ -6344,8 +6195,8 @@
         </p:nvSpPr>
         <p:spPr>
           <a:xfrm>
-            <a:off x="731520" y="457200"/>
-            <a:ext cx="10698480" cy="365760"/>
+            <a:off x="731520" y="365760"/>
+            <a:ext cx="10698480" cy="320040"/>
           </a:xfrm>
           <a:prstGeom prst="rect">
             <a:avLst/>
@@ -6363,7 +6214,6 @@
                 <a:solidFill>
                   <a:srgbClr val="D4A843"/>
                 </a:solidFill>
-                <a:latin typeface="Arial"/>
               </a:defRPr>
             </a:pPr>
             <a:r>
@@ -6380,8 +6230,8 @@
         </p:nvSpPr>
         <p:spPr>
           <a:xfrm>
-            <a:off x="731520" y="777240"/>
-            <a:ext cx="10698480" cy="731520"/>
+            <a:off x="731520" y="685800"/>
+            <a:ext cx="10698480" cy="685800"/>
           </a:xfrm>
           <a:prstGeom prst="rect">
             <a:avLst/>
@@ -6395,15 +6245,14 @@
           <a:lstStyle/>
           <a:p>
             <a:pPr>
-              <a:defRPr sz="2600" b="1">
+              <a:defRPr sz="2400" b="1">
                 <a:solidFill>
                   <a:srgbClr val="FFFFFF"/>
                 </a:solidFill>
-                <a:latin typeface="Arial"/>
-              </a:defRPr>
-            </a:pPr>
-            <a:r>
-              <a:t>Структура расходов</a:t>
+              </a:defRPr>
+            </a:pPr>
+            <a:r>
+              <a:t>8. Ключевые партнёры</a:t>
             </a:r>
           </a:p>
         </p:txBody>
@@ -6416,8 +6265,8 @@
         </p:nvSpPr>
         <p:spPr>
           <a:xfrm>
-            <a:off x="731520" y="1645920"/>
-            <a:ext cx="5212080" cy="4572000"/>
+            <a:off x="731520" y="1463040"/>
+            <a:ext cx="5212080" cy="2286000"/>
           </a:xfrm>
           <a:prstGeom prst="rect">
             <a:avLst/>
@@ -6461,8 +6310,8 @@
         </p:nvSpPr>
         <p:spPr>
           <a:xfrm>
-            <a:off x="1005840" y="1920240"/>
-            <a:ext cx="4663440" cy="4023360"/>
+            <a:off x="960120" y="1645920"/>
+            <a:ext cx="4754880" cy="1920240"/>
           </a:xfrm>
           <a:prstGeom prst="rect">
             <a:avLst/>
@@ -6476,125 +6325,41 @@
           <a:lstStyle/>
           <a:p>
             <a:pPr>
+              <a:defRPr sz="1400" b="1">
+                <a:solidFill>
+                  <a:srgbClr val="D4A843"/>
+                </a:solidFill>
+              </a:defRPr>
+            </a:pPr>
+            <a:r>
+              <a:t>🖥️ Инфраструктура</a:t>
+            </a:r>
+          </a:p>
+          <a:p>
+            <a:pPr>
               <a:spcAft>
-                <a:spcPts val="1400"/>
+                <a:spcPts val="400"/>
               </a:spcAft>
-              <a:defRPr sz="2000" b="1">
-                <a:solidFill>
-                  <a:srgbClr val="D4A843"/>
-                </a:solidFill>
-              </a:defRPr>
-            </a:pPr>
-            <a:r>
-              <a:t>📅 Ежемесячные затраты</a:t>
-            </a:r>
-          </a:p>
-          <a:p>
-            <a:pPr>
-              <a:defRPr sz="1500" b="1">
+              <a:defRPr sz="1800" b="1">
                 <a:solidFill>
                   <a:srgbClr val="FFFFFF"/>
                 </a:solidFill>
               </a:defRPr>
             </a:pPr>
             <a:r>
-              <a:t>• Зарплата кураторов (3 чел): 750 000 ₸</a:t>
-            </a:r>
-          </a:p>
-          <a:p>
-            <a:pPr>
-              <a:spcAft>
-                <a:spcPts val="600"/>
-              </a:spcAft>
+              <a:t>Хостинг-провайдеры</a:t>
+            </a:r>
+          </a:p>
+          <a:p>
+            <a:pPr>
               <a:defRPr sz="1200">
                 <a:solidFill>
-                  <a:srgbClr val="AAB9CD"/>
-                </a:solidFill>
-              </a:defRPr>
-            </a:pPr>
-            <a:r>
-              <a:t>   (3 × 250 000 ₸ в месяц)</a:t>
-            </a:r>
-          </a:p>
-          <a:p>
-            <a:pPr>
-              <a:defRPr sz="1500" b="1">
-                <a:solidFill>
-                  <a:srgbClr val="FFFFFF"/>
-                </a:solidFill>
-              </a:defRPr>
-            </a:pPr>
-            <a:r>
-              <a:t>• Зарплата администратора: 280 000 ₸</a:t>
-            </a:r>
-          </a:p>
-          <a:p>
-            <a:pPr>
-              <a:spcAft>
-                <a:spcPts val="600"/>
-              </a:spcAft>
-              <a:defRPr sz="1200">
-                <a:solidFill>
-                  <a:srgbClr val="AAB9CD"/>
-                </a:solidFill>
-              </a:defRPr>
-            </a:pPr>
-            <a:r>
-              <a:t>   (1 специалист)</a:t>
-            </a:r>
-          </a:p>
-          <a:p>
-            <a:pPr>
-              <a:defRPr sz="1500" b="1">
-                <a:solidFill>
-                  <a:srgbClr val="FFFFFF"/>
-                </a:solidFill>
-              </a:defRPr>
-            </a:pPr>
-            <a:r>
-              <a:t>• Хостинг и серверы: 20 000 ₸</a:t>
-            </a:r>
-          </a:p>
-          <a:p>
-            <a:pPr>
-              <a:spcAft>
-                <a:spcPts val="600"/>
-              </a:spcAft>
-              <a:defRPr sz="1200">
-                <a:solidFill>
-                  <a:srgbClr val="AAB9CD"/>
-                </a:solidFill>
-              </a:defRPr>
-            </a:pPr>
-            <a:r>
-              <a:t>   (Поддержка веб-инфраструктуры)</a:t>
-            </a:r>
-          </a:p>
-          <a:p>
-            <a:pPr>
-              <a:defRPr sz="1500" b="1">
-                <a:solidFill>
-                  <a:srgbClr val="FFFFFF"/>
-                </a:solidFill>
-              </a:defRPr>
-            </a:pPr>
-            <a:r>
-              <a:t>• Реклама и промоутеры: 120 000 ₸</a:t>
-            </a:r>
-          </a:p>
-          <a:p>
-            <a:pPr>
-              <a:spcAft>
-                <a:spcPts val="600"/>
-              </a:spcAft>
-              <a:defRPr sz="1200">
-                <a:solidFill>
-                  <a:srgbClr val="AAB9CD"/>
-                </a:solidFill>
-              </a:defRPr>
-            </a:pPr>
-            <a:r>
-              <a:t>   (Ежемесячный маркетинговый бюджет)</a:t>
+                  <a:srgbClr val="F5F7FA"/>
+                </a:solidFill>
+              </a:defRPr>
+            </a:pPr>
+            <a:r>
+              <a:t>Обеспечение стабильной работы веб-сайта, платформы обучения и Телеграм-бота.</a:t>
             </a:r>
           </a:p>
         </p:txBody>
@@ -6607,8 +6372,8 @@
         </p:nvSpPr>
         <p:spPr>
           <a:xfrm>
-            <a:off x="6248095" y="1645920"/>
-            <a:ext cx="5212080" cy="4572000"/>
+            <a:off x="6248095" y="1463040"/>
+            <a:ext cx="5212080" cy="2286000"/>
           </a:xfrm>
           <a:prstGeom prst="rect">
             <a:avLst/>
@@ -6652,8 +6417,8 @@
         </p:nvSpPr>
         <p:spPr>
           <a:xfrm>
-            <a:off x="6522415" y="1920240"/>
-            <a:ext cx="4663440" cy="4023360"/>
+            <a:off x="6476695" y="1645920"/>
+            <a:ext cx="4754880" cy="1920240"/>
           </a:xfrm>
           <a:prstGeom prst="rect">
             <a:avLst/>
@@ -6667,68 +6432,255 @@
           <a:lstStyle/>
           <a:p>
             <a:pPr>
+              <a:defRPr sz="1400" b="1">
+                <a:solidFill>
+                  <a:srgbClr val="D4A843"/>
+                </a:solidFill>
+              </a:defRPr>
+            </a:pPr>
+            <a:r>
+              <a:t>🎓 Образование &amp; Продвижение</a:t>
+            </a:r>
+          </a:p>
+          <a:p>
+            <a:pPr>
               <a:spcAft>
-                <a:spcPts val="1400"/>
+                <a:spcPts val="400"/>
               </a:spcAft>
-              <a:defRPr sz="2000" b="1">
-                <a:solidFill>
-                  <a:srgbClr val="1A8A8A"/>
-                </a:solidFill>
-              </a:defRPr>
-            </a:pPr>
-            <a:r>
-              <a:t>⚡ Разовые расходы и Итого</a:t>
-            </a:r>
-          </a:p>
-          <a:p>
-            <a:pPr>
-              <a:defRPr sz="1500" b="1">
+              <a:defRPr sz="1800" b="1">
                 <a:solidFill>
                   <a:srgbClr val="FFFFFF"/>
                 </a:solidFill>
               </a:defRPr>
             </a:pPr>
             <a:r>
-              <a:t>• Первичная реклама и старт: 300 000 ₸</a:t>
+              <a:t>Школы Казахстана</a:t>
+            </a:r>
+          </a:p>
+          <a:p>
+            <a:pPr>
+              <a:defRPr sz="1200">
+                <a:solidFill>
+                  <a:srgbClr val="F5F7FA"/>
+                </a:solidFill>
+              </a:defRPr>
+            </a:pPr>
+            <a:r>
+              <a:t>Привлечение школьников и проведение совместных открытых уроков и цифровой грамотности.</a:t>
+            </a:r>
+          </a:p>
+        </p:txBody>
+      </p:sp>
+      <p:sp>
+        <p:nvSpPr>
+          <p:cNvPr id="8" name="Rectangle 7"/>
+          <p:cNvSpPr/>
+          <p:nvPr/>
+        </p:nvSpPr>
+        <p:spPr>
+          <a:xfrm>
+            <a:off x="731520" y="3931920"/>
+            <a:ext cx="5212080" cy="2286000"/>
+          </a:xfrm>
+          <a:prstGeom prst="rect">
+            <a:avLst/>
+          </a:prstGeom>
+          <a:solidFill>
+            <a:srgbClr val="12233C"/>
+          </a:solidFill>
+          <a:ln w="12700">
+            <a:solidFill>
+              <a:srgbClr val="233C5F"/>
+            </a:solidFill>
+          </a:ln>
+        </p:spPr>
+        <p:style>
+          <a:lnRef idx="1">
+            <a:schemeClr val="accent1"/>
+          </a:lnRef>
+          <a:fillRef idx="3">
+            <a:schemeClr val="accent1"/>
+          </a:fillRef>
+          <a:effectRef idx="2">
+            <a:schemeClr val="accent1"/>
+          </a:effectRef>
+          <a:fontRef idx="minor">
+            <a:schemeClr val="lt1"/>
+          </a:fontRef>
+        </p:style>
+        <p:txBody>
+          <a:bodyPr rtlCol="0" anchor="ctr"/>
+          <a:lstStyle/>
+          <a:p>
+            <a:pPr algn="ctr"/>
+          </a:p>
+        </p:txBody>
+      </p:sp>
+      <p:sp>
+        <p:nvSpPr>
+          <p:cNvPr id="9" name="TextBox 8"/>
+          <p:cNvSpPr txBox="1"/>
+          <p:nvPr/>
+        </p:nvSpPr>
+        <p:spPr>
+          <a:xfrm>
+            <a:off x="960120" y="4114800"/>
+            <a:ext cx="4754880" cy="1920240"/>
+          </a:xfrm>
+          <a:prstGeom prst="rect">
+            <a:avLst/>
+          </a:prstGeom>
+          <a:noFill/>
+        </p:spPr>
+        <p:txBody>
+          <a:bodyPr wrap="square">
+            <a:spAutoFit/>
+          </a:bodyPr>
+          <a:lstStyle/>
+          <a:p>
+            <a:pPr>
+              <a:defRPr sz="1400" b="1">
+                <a:solidFill>
+                  <a:srgbClr val="D4A843"/>
+                </a:solidFill>
+              </a:defRPr>
+            </a:pPr>
+            <a:r>
+              <a:t>📣 Инфлюенсеры &amp; Маркетинг</a:t>
             </a:r>
           </a:p>
           <a:p>
             <a:pPr>
               <a:spcAft>
-                <a:spcPts val="2000"/>
+                <a:spcPts val="400"/>
               </a:spcAft>
+              <a:defRPr sz="1800" b="1">
+                <a:solidFill>
+                  <a:srgbClr val="FFFFFF"/>
+                </a:solidFill>
+              </a:defRPr>
+            </a:pPr>
+            <a:r>
+              <a:t>Instagram &amp; Telegram</a:t>
+            </a:r>
+          </a:p>
+          <a:p>
+            <a:pPr>
               <a:defRPr sz="1200">
                 <a:solidFill>
-                  <a:srgbClr val="AAB9CD"/>
-                </a:solidFill>
-              </a:defRPr>
-            </a:pPr>
-            <a:r>
-              <a:t>   Стартовый маркетинг для первого набора учеников.</a:t>
-            </a:r>
-          </a:p>
-          <a:p>
-            <a:pPr>
-              <a:defRPr sz="1400">
-                <a:solidFill>
-                  <a:srgbClr val="AAB9CD"/>
-                </a:solidFill>
-              </a:defRPr>
-            </a:pPr>
-            <a:r>
-              <a:t>Итого постоянные расходы:</a:t>
-            </a:r>
-          </a:p>
-          <a:p>
-            <a:pPr>
-              <a:defRPr sz="2400" b="1">
+                  <a:srgbClr val="F5F7FA"/>
+                </a:solidFill>
+              </a:defRPr>
+            </a:pPr>
+            <a:r>
+              <a:t>Сотрудничество с инфлюенсерами, рекламными площадками и работа промоутеров.</a:t>
+            </a:r>
+          </a:p>
+        </p:txBody>
+      </p:sp>
+      <p:sp>
+        <p:nvSpPr>
+          <p:cNvPr id="10" name="Rectangle 9"/>
+          <p:cNvSpPr/>
+          <p:nvPr/>
+        </p:nvSpPr>
+        <p:spPr>
+          <a:xfrm>
+            <a:off x="6248095" y="3931920"/>
+            <a:ext cx="5212080" cy="2286000"/>
+          </a:xfrm>
+          <a:prstGeom prst="rect">
+            <a:avLst/>
+          </a:prstGeom>
+          <a:solidFill>
+            <a:srgbClr val="12233C"/>
+          </a:solidFill>
+          <a:ln w="12700">
+            <a:solidFill>
+              <a:srgbClr val="233C5F"/>
+            </a:solidFill>
+          </a:ln>
+        </p:spPr>
+        <p:style>
+          <a:lnRef idx="1">
+            <a:schemeClr val="accent1"/>
+          </a:lnRef>
+          <a:fillRef idx="3">
+            <a:schemeClr val="accent1"/>
+          </a:fillRef>
+          <a:effectRef idx="2">
+            <a:schemeClr val="accent1"/>
+          </a:effectRef>
+          <a:fontRef idx="minor">
+            <a:schemeClr val="lt1"/>
+          </a:fontRef>
+        </p:style>
+        <p:txBody>
+          <a:bodyPr rtlCol="0" anchor="ctr"/>
+          <a:lstStyle/>
+          <a:p>
+            <a:pPr algn="ctr"/>
+          </a:p>
+        </p:txBody>
+      </p:sp>
+      <p:sp>
+        <p:nvSpPr>
+          <p:cNvPr id="11" name="TextBox 10"/>
+          <p:cNvSpPr txBox="1"/>
+          <p:nvPr/>
+        </p:nvSpPr>
+        <p:spPr>
+          <a:xfrm>
+            <a:off x="6476695" y="4114800"/>
+            <a:ext cx="4754880" cy="1920240"/>
+          </a:xfrm>
+          <a:prstGeom prst="rect">
+            <a:avLst/>
+          </a:prstGeom>
+          <a:noFill/>
+        </p:spPr>
+        <p:txBody>
+          <a:bodyPr wrap="square">
+            <a:spAutoFit/>
+          </a:bodyPr>
+          <a:lstStyle/>
+          <a:p>
+            <a:pPr>
+              <a:defRPr sz="1400" b="1">
                 <a:solidFill>
                   <a:srgbClr val="D4A843"/>
                 </a:solidFill>
               </a:defRPr>
             </a:pPr>
             <a:r>
-              <a:t>1 170 000 ₸ / месяц</a:t>
+              <a:t>🤝 Партнерство с онлайн-школами</a:t>
+            </a:r>
+          </a:p>
+          <a:p>
+            <a:pPr>
+              <a:spcAft>
+                <a:spcPts val="400"/>
+              </a:spcAft>
+              <a:defRPr sz="1800" b="1">
+                <a:solidFill>
+                  <a:srgbClr val="FFFFFF"/>
+                </a:solidFill>
+              </a:defRPr>
+            </a:pPr>
+            <a:r>
+              <a:t>Коллаборации</a:t>
+            </a:r>
+          </a:p>
+          <a:p>
+            <a:pPr>
+              <a:defRPr sz="1200">
+                <a:solidFill>
+                  <a:srgbClr val="F5F7FA"/>
+                </a:solidFill>
+              </a:defRPr>
+            </a:pPr>
+            <a:r>
+              <a:t>Возможно сотрудничество с другими онлайн-школами, дополняющими наши курсы.</a:t>
             </a:r>
           </a:p>
         </p:txBody>
@@ -6767,8 +6719,8 @@
         </p:nvSpPr>
         <p:spPr>
           <a:xfrm>
-            <a:off x="731520" y="457200"/>
-            <a:ext cx="10698480" cy="365760"/>
+            <a:off x="731520" y="365760"/>
+            <a:ext cx="10698480" cy="320040"/>
           </a:xfrm>
           <a:prstGeom prst="rect">
             <a:avLst/>
@@ -6786,7 +6738,6 @@
                 <a:solidFill>
                   <a:srgbClr val="D4A843"/>
                 </a:solidFill>
-                <a:latin typeface="Arial"/>
               </a:defRPr>
             </a:pPr>
             <a:r>
@@ -6803,8 +6754,8 @@
         </p:nvSpPr>
         <p:spPr>
           <a:xfrm>
-            <a:off x="731520" y="777240"/>
-            <a:ext cx="10698480" cy="731520"/>
+            <a:off x="731520" y="685800"/>
+            <a:ext cx="10698480" cy="685800"/>
           </a:xfrm>
           <a:prstGeom prst="rect">
             <a:avLst/>
@@ -6818,15 +6769,14 @@
           <a:lstStyle/>
           <a:p>
             <a:pPr>
-              <a:defRPr sz="2600" b="1">
+              <a:defRPr sz="2400" b="1">
                 <a:solidFill>
                   <a:srgbClr val="FFFFFF"/>
                 </a:solidFill>
-                <a:latin typeface="Arial"/>
-              </a:defRPr>
-            </a:pPr>
-            <a:r>
-              <a:t>Финансовые результаты за 5 месяцев</a:t>
+              </a:defRPr>
+            </a:pPr>
+            <a:r>
+              <a:t>9. Структура расходов и Расчет прибыли</a:t>
             </a:r>
           </a:p>
         </p:txBody>
@@ -6839,8 +6789,8 @@
         </p:nvSpPr>
         <p:spPr>
           <a:xfrm>
-            <a:off x="731520" y="1645920"/>
-            <a:ext cx="3413455" cy="2011680"/>
+            <a:off x="731520" y="1463040"/>
+            <a:ext cx="5212080" cy="4754880"/>
           </a:xfrm>
           <a:prstGeom prst="rect">
             <a:avLst/>
@@ -6884,8 +6834,8 @@
         </p:nvSpPr>
         <p:spPr>
           <a:xfrm>
-            <a:off x="914400" y="1783080"/>
-            <a:ext cx="3047695" cy="1737360"/>
+            <a:off x="1005840" y="1691640"/>
+            <a:ext cx="4663440" cy="4297680"/>
           </a:xfrm>
           <a:prstGeom prst="rect">
             <a:avLst/>
@@ -6899,29 +6849,29 @@
           <a:lstStyle/>
           <a:p>
             <a:pPr>
-              <a:defRPr sz="2400" b="1">
+              <a:spcAft>
+                <a:spcPts val="1000"/>
+              </a:spcAft>
+              <a:defRPr sz="1900" b="1">
                 <a:solidFill>
                   <a:srgbClr val="D4A843"/>
                 </a:solidFill>
               </a:defRPr>
             </a:pPr>
             <a:r>
-              <a:t>144 → 115</a:t>
-            </a:r>
-          </a:p>
-          <a:p>
-            <a:pPr>
-              <a:spcAft>
-                <a:spcPts val="400"/>
-              </a:spcAft>
-              <a:defRPr sz="1600" b="1">
+              <a:t>📋 Ежемесячные затраты</a:t>
+            </a:r>
+          </a:p>
+          <a:p>
+            <a:pPr>
+              <a:defRPr sz="1300" b="1">
                 <a:solidFill>
                   <a:srgbClr val="FFFFFF"/>
                 </a:solidFill>
               </a:defRPr>
             </a:pPr>
             <a:r>
-              <a:t>Студентов</a:t>
+              <a:t>• Зарплата кураторов (3 чел): 750 000 ₸</a:t>
             </a:r>
           </a:p>
           <a:p>
@@ -6933,7 +6883,127 @@
               </a:defRPr>
             </a:pPr>
             <a:r>
-              <a:t>Плановый набор 144 места, с учетом 20% отвала фактически обучаются 115 человек</a:t>
+              <a:t>   (3 × 250 000 ₸)</a:t>
+            </a:r>
+          </a:p>
+          <a:p>
+            <a:pPr>
+              <a:defRPr sz="1300" b="1">
+                <a:solidFill>
+                  <a:srgbClr val="FFFFFF"/>
+                </a:solidFill>
+              </a:defRPr>
+            </a:pPr>
+            <a:r>
+              <a:t>• Зарплата администратора: 280 000 ₸</a:t>
+            </a:r>
+          </a:p>
+          <a:p>
+            <a:pPr>
+              <a:defRPr sz="1100">
+                <a:solidFill>
+                  <a:srgbClr val="AAB9CD"/>
+                </a:solidFill>
+              </a:defRPr>
+            </a:pPr>
+            <a:r>
+              <a:t>   (1 администратор)</a:t>
+            </a:r>
+          </a:p>
+          <a:p>
+            <a:pPr>
+              <a:defRPr sz="1300" b="1">
+                <a:solidFill>
+                  <a:srgbClr val="FFFFFF"/>
+                </a:solidFill>
+              </a:defRPr>
+            </a:pPr>
+            <a:r>
+              <a:t>• Хостинг: 20 000 ₸</a:t>
+            </a:r>
+          </a:p>
+          <a:p>
+            <a:pPr>
+              <a:defRPr sz="1100">
+                <a:solidFill>
+                  <a:srgbClr val="AAB9CD"/>
+                </a:solidFill>
+              </a:defRPr>
+            </a:pPr>
+            <a:r>
+              <a:t>   (Поддержка сайта)</a:t>
+            </a:r>
+          </a:p>
+          <a:p>
+            <a:pPr>
+              <a:defRPr sz="1300" b="1">
+                <a:solidFill>
+                  <a:srgbClr val="FFFFFF"/>
+                </a:solidFill>
+              </a:defRPr>
+            </a:pPr>
+            <a:r>
+              <a:t>• Буст Discord сервера: 17 000 ₸</a:t>
+            </a:r>
+          </a:p>
+          <a:p>
+            <a:pPr>
+              <a:defRPr sz="1100">
+                <a:solidFill>
+                  <a:srgbClr val="AAB9CD"/>
+                </a:solidFill>
+              </a:defRPr>
+            </a:pPr>
+            <a:r>
+              <a:t>   (Улучшение качества связи)</a:t>
+            </a:r>
+          </a:p>
+          <a:p>
+            <a:pPr>
+              <a:defRPr sz="1300" b="1">
+                <a:solidFill>
+                  <a:srgbClr val="FFFFFF"/>
+                </a:solidFill>
+              </a:defRPr>
+            </a:pPr>
+            <a:r>
+              <a:t>• Реклама и промоутеры: 300 000 ₸</a:t>
+            </a:r>
+          </a:p>
+          <a:p>
+            <a:pPr>
+              <a:defRPr sz="1100">
+                <a:solidFill>
+                  <a:srgbClr val="AAB9CD"/>
+                </a:solidFill>
+              </a:defRPr>
+            </a:pPr>
+            <a:r>
+              <a:t>   (Маркетинговый бюджет)</a:t>
+            </a:r>
+          </a:p>
+          <a:p>
+            <a:pPr>
+              <a:defRPr sz="1300" b="1">
+                <a:solidFill>
+                  <a:srgbClr val="FFFFFF"/>
+                </a:solidFill>
+              </a:defRPr>
+            </a:pPr>
+            <a:r>
+              <a:t>• Подоходный налог (ИП 4%): 119 300 ₸</a:t>
+            </a:r>
+          </a:p>
+          <a:p>
+            <a:pPr>
+              <a:defRPr sz="1100">
+                <a:solidFill>
+                  <a:srgbClr val="AAB9CD"/>
+                </a:solidFill>
+              </a:defRPr>
+            </a:pPr>
+            <a:r>
+              <a:t>   (4% от дохода 2 980 800 ₸)</a:t>
             </a:r>
           </a:p>
         </p:txBody>
@@ -6946,8 +7016,8 @@
         </p:nvSpPr>
         <p:spPr>
           <a:xfrm>
-            <a:off x="4389120" y="1645920"/>
-            <a:ext cx="3413455" cy="2011680"/>
+            <a:off x="6248095" y="1463040"/>
+            <a:ext cx="5212080" cy="4754880"/>
           </a:xfrm>
           <a:prstGeom prst="rect">
             <a:avLst/>
@@ -6991,8 +7061,8 @@
         </p:nvSpPr>
         <p:spPr>
           <a:xfrm>
-            <a:off x="4572000" y="1783080"/>
-            <a:ext cx="3047695" cy="1737360"/>
+            <a:off x="6522415" y="1691640"/>
+            <a:ext cx="4663440" cy="4297680"/>
           </a:xfrm>
           <a:prstGeom prst="rect">
             <a:avLst/>
@@ -7006,346 +7076,87 @@
           <a:lstStyle/>
           <a:p>
             <a:pPr>
-              <a:defRPr sz="2400" b="1">
-                <a:solidFill>
-                  <a:srgbClr val="D4A843"/>
-                </a:solidFill>
-              </a:defRPr>
-            </a:pPr>
-            <a:r>
-              <a:t>11 649 000 ₸</a:t>
-            </a:r>
-          </a:p>
-          <a:p>
-            <a:pPr>
               <a:spcAft>
-                <a:spcPts val="400"/>
+                <a:spcPts val="800"/>
               </a:spcAft>
-              <a:defRPr sz="1600" b="1">
-                <a:solidFill>
-                  <a:srgbClr val="FFFFFF"/>
-                </a:solidFill>
-              </a:defRPr>
-            </a:pPr>
-            <a:r>
-              <a:t>Общий доход</a:t>
-            </a:r>
-          </a:p>
-          <a:p>
-            <a:pPr>
-              <a:defRPr sz="1100">
-                <a:solidFill>
-                  <a:srgbClr val="AAB9CD"/>
-                </a:solidFill>
-              </a:defRPr>
-            </a:pPr>
-            <a:r>
-              <a:t>Совокупный финансовый поток от подписок за 5 месяцев работы</a:t>
-            </a:r>
-          </a:p>
-        </p:txBody>
-      </p:sp>
-      <p:sp>
-        <p:nvSpPr>
-          <p:cNvPr id="8" name="Rectangle 7"/>
-          <p:cNvSpPr/>
-          <p:nvPr/>
-        </p:nvSpPr>
-        <p:spPr>
-          <a:xfrm>
-            <a:off x="8046720" y="1645920"/>
-            <a:ext cx="3413455" cy="2011680"/>
-          </a:xfrm>
-          <a:prstGeom prst="rect">
-            <a:avLst/>
-          </a:prstGeom>
-          <a:solidFill>
-            <a:srgbClr val="12233C"/>
-          </a:solidFill>
-          <a:ln w="12700">
-            <a:solidFill>
-              <a:srgbClr val="233C5F"/>
-            </a:solidFill>
-          </a:ln>
-        </p:spPr>
-        <p:style>
-          <a:lnRef idx="1">
-            <a:schemeClr val="accent1"/>
-          </a:lnRef>
-          <a:fillRef idx="3">
-            <a:schemeClr val="accent1"/>
-          </a:fillRef>
-          <a:effectRef idx="2">
-            <a:schemeClr val="accent1"/>
-          </a:effectRef>
-          <a:fontRef idx="minor">
-            <a:schemeClr val="lt1"/>
-          </a:fontRef>
-        </p:style>
-        <p:txBody>
-          <a:bodyPr rtlCol="0" anchor="ctr"/>
-          <a:lstStyle/>
-          <a:p>
-            <a:pPr algn="ctr"/>
-          </a:p>
-        </p:txBody>
-      </p:sp>
-      <p:sp>
-        <p:nvSpPr>
-          <p:cNvPr id="9" name="TextBox 8"/>
-          <p:cNvSpPr txBox="1"/>
-          <p:nvPr/>
-        </p:nvSpPr>
-        <p:spPr>
-          <a:xfrm>
-            <a:off x="8229600" y="1783080"/>
-            <a:ext cx="3047695" cy="1737360"/>
-          </a:xfrm>
-          <a:prstGeom prst="rect">
-            <a:avLst/>
-          </a:prstGeom>
-          <a:noFill/>
-        </p:spPr>
-        <p:txBody>
-          <a:bodyPr wrap="square">
-            <a:spAutoFit/>
-          </a:bodyPr>
-          <a:lstStyle/>
-          <a:p>
-            <a:pPr>
-              <a:defRPr sz="2400" b="1">
-                <a:solidFill>
-                  <a:srgbClr val="D4A843"/>
-                </a:solidFill>
-              </a:defRPr>
-            </a:pPr>
-            <a:r>
-              <a:t>5 551 915 ₸</a:t>
-            </a:r>
-          </a:p>
-          <a:p>
-            <a:pPr>
-              <a:spcAft>
-                <a:spcPts val="400"/>
-              </a:spcAft>
-              <a:defRPr sz="1600" b="1">
-                <a:solidFill>
-                  <a:srgbClr val="FFFFFF"/>
-                </a:solidFill>
-              </a:defRPr>
-            </a:pPr>
-            <a:r>
-              <a:t>Чистая прибыль</a:t>
-            </a:r>
-          </a:p>
-          <a:p>
-            <a:pPr>
-              <a:defRPr sz="1100">
-                <a:solidFill>
-                  <a:srgbClr val="AAB9CD"/>
-                </a:solidFill>
-              </a:defRPr>
-            </a:pPr>
-            <a:r>
-              <a:t>С учетом всех расходов и налога ИП 4% с оборота (расходы: 6 097 085 ₸)</a:t>
-            </a:r>
-          </a:p>
-        </p:txBody>
-      </p:sp>
-      <p:sp>
-        <p:nvSpPr>
-          <p:cNvPr id="10" name="Rectangle 9"/>
-          <p:cNvSpPr/>
-          <p:nvPr/>
-        </p:nvSpPr>
-        <p:spPr>
-          <a:xfrm>
-            <a:off x="731520" y="3931920"/>
-            <a:ext cx="5212080" cy="2286000"/>
-          </a:xfrm>
-          <a:prstGeom prst="rect">
-            <a:avLst/>
-          </a:prstGeom>
-          <a:solidFill>
-            <a:srgbClr val="12233C"/>
-          </a:solidFill>
-          <a:ln w="12700">
-            <a:solidFill>
-              <a:srgbClr val="233C5F"/>
-            </a:solidFill>
-          </a:ln>
-        </p:spPr>
-        <p:style>
-          <a:lnRef idx="1">
-            <a:schemeClr val="accent1"/>
-          </a:lnRef>
-          <a:fillRef idx="3">
-            <a:schemeClr val="accent1"/>
-          </a:fillRef>
-          <a:effectRef idx="2">
-            <a:schemeClr val="accent1"/>
-          </a:effectRef>
-          <a:fontRef idx="minor">
-            <a:schemeClr val="lt1"/>
-          </a:fontRef>
-        </p:style>
-        <p:txBody>
-          <a:bodyPr rtlCol="0" anchor="ctr"/>
-          <a:lstStyle/>
-          <a:p>
-            <a:pPr algn="ctr"/>
-          </a:p>
-        </p:txBody>
-      </p:sp>
-      <p:sp>
-        <p:nvSpPr>
-          <p:cNvPr id="11" name="TextBox 10"/>
-          <p:cNvSpPr txBox="1"/>
-          <p:nvPr/>
-        </p:nvSpPr>
-        <p:spPr>
-          <a:xfrm>
-            <a:off x="1005840" y="4114800"/>
-            <a:ext cx="4663440" cy="1920240"/>
-          </a:xfrm>
-          <a:prstGeom prst="rect">
-            <a:avLst/>
-          </a:prstGeom>
-          <a:noFill/>
-        </p:spPr>
-        <p:txBody>
-          <a:bodyPr wrap="square">
-            <a:spAutoFit/>
-          </a:bodyPr>
-          <a:lstStyle/>
+              <a:defRPr sz="1900" b="1">
+                <a:solidFill>
+                  <a:srgbClr val="1A8A8A"/>
+                </a:solidFill>
+              </a:defRPr>
+            </a:pPr>
+            <a:r>
+              <a:t>💵 Расчет чистой прибыли</a:t>
+            </a:r>
+          </a:p>
           <a:p>
             <a:pPr>
               <a:spcAft>
                 <a:spcPts val="600"/>
               </a:spcAft>
-              <a:defRPr sz="1800" b="1">
-                <a:solidFill>
-                  <a:srgbClr val="1A8A8A"/>
-                </a:solidFill>
-              </a:defRPr>
-            </a:pPr>
-            <a:r>
-              <a:t>⚡ Высокая окупаемость</a:t>
-            </a:r>
-          </a:p>
-          <a:p>
-            <a:pPr>
-              <a:defRPr sz="1300">
+              <a:defRPr sz="1100">
+                <a:solidFill>
+                  <a:srgbClr val="AAB9CD"/>
+                </a:solidFill>
+              </a:defRPr>
+            </a:pPr>
+            <a:r>
+              <a:t>2 980 800 − 119 300 − 750 000 − 280 000 − 20 000 − 17 000 − 300 000</a:t>
+            </a:r>
+          </a:p>
+          <a:p>
+            <a:pPr>
+              <a:defRPr sz="1400">
+                <a:solidFill>
+                  <a:srgbClr val="FFFFFF"/>
+                </a:solidFill>
+              </a:defRPr>
+            </a:pPr>
+            <a:r>
+              <a:t>Чистая прибыль в месяц:</a:t>
+            </a:r>
+          </a:p>
+          <a:p>
+            <a:pPr>
+              <a:spcAft>
+                <a:spcPts val="1600"/>
+              </a:spcAft>
+              <a:defRPr sz="2800" b="1">
+                <a:solidFill>
+                  <a:srgbClr val="D4A843"/>
+                </a:solidFill>
+              </a:defRPr>
+            </a:pPr>
+            <a:r>
+              <a:t>1 494 500 ₸</a:t>
+            </a:r>
+          </a:p>
+          <a:p>
+            <a:pPr>
+              <a:defRPr sz="1500" b="1">
+                <a:solidFill>
+                  <a:srgbClr val="FFFFFF"/>
+                </a:solidFill>
+              </a:defRPr>
+            </a:pPr>
+            <a:r>
+              <a:t>💼 Стартовый капитал:</a:t>
+            </a:r>
+          </a:p>
+          <a:p>
+            <a:pPr>
+              <a:defRPr sz="1200">
                 <a:solidFill>
                   <a:srgbClr val="F5F7FA"/>
                 </a:solidFill>
               </a:defRPr>
             </a:pPr>
             <a:r>
-              <a:t>Проект самоокупаем с первого месяца!</a:t>
+              <a:t>• Для запуска не требуется кредит.</a:t>
             </a:r>
             <a:br/>
             <a:r>
-              <a:t>Доход 1-го месяца составляет 2,6 млн ₸, что полностью покрывает расходы и приносит &gt;1,1 млн ₸ чистой прибыли.</a:t>
-            </a:r>
-          </a:p>
-        </p:txBody>
-      </p:sp>
-      <p:sp>
-        <p:nvSpPr>
-          <p:cNvPr id="12" name="Rectangle 11"/>
-          <p:cNvSpPr/>
-          <p:nvPr/>
-        </p:nvSpPr>
-        <p:spPr>
-          <a:xfrm>
-            <a:off x="6248095" y="3931920"/>
-            <a:ext cx="5212080" cy="2286000"/>
-          </a:xfrm>
-          <a:prstGeom prst="rect">
-            <a:avLst/>
-          </a:prstGeom>
-          <a:solidFill>
-            <a:srgbClr val="12233C"/>
-          </a:solidFill>
-          <a:ln w="12700">
-            <a:solidFill>
-              <a:srgbClr val="233C5F"/>
-            </a:solidFill>
-          </a:ln>
-        </p:spPr>
-        <p:style>
-          <a:lnRef idx="1">
-            <a:schemeClr val="accent1"/>
-          </a:lnRef>
-          <a:fillRef idx="3">
-            <a:schemeClr val="accent1"/>
-          </a:fillRef>
-          <a:effectRef idx="2">
-            <a:schemeClr val="accent1"/>
-          </a:effectRef>
-          <a:fontRef idx="minor">
-            <a:schemeClr val="lt1"/>
-          </a:fontRef>
-        </p:style>
-        <p:txBody>
-          <a:bodyPr rtlCol="0" anchor="ctr"/>
-          <a:lstStyle/>
-          <a:p>
-            <a:pPr algn="ctr"/>
-          </a:p>
-        </p:txBody>
-      </p:sp>
-      <p:sp>
-        <p:nvSpPr>
-          <p:cNvPr id="13" name="TextBox 12"/>
-          <p:cNvSpPr txBox="1"/>
-          <p:nvPr/>
-        </p:nvSpPr>
-        <p:spPr>
-          <a:xfrm>
-            <a:off x="6522415" y="4114800"/>
-            <a:ext cx="4663440" cy="1920240"/>
-          </a:xfrm>
-          <a:prstGeom prst="rect">
-            <a:avLst/>
-          </a:prstGeom>
-          <a:noFill/>
-        </p:spPr>
-        <p:txBody>
-          <a:bodyPr wrap="square">
-            <a:spAutoFit/>
-          </a:bodyPr>
-          <a:lstStyle/>
-          <a:p>
-            <a:pPr>
-              <a:spcAft>
-                <a:spcPts val="600"/>
-              </a:spcAft>
-              <a:defRPr sz="1800" b="1">
-                <a:solidFill>
-                  <a:srgbClr val="D4A843"/>
-                </a:solidFill>
-              </a:defRPr>
-            </a:pPr>
-            <a:r>
-              <a:t>💼 Стартовый капитал</a:t>
-            </a:r>
-          </a:p>
-          <a:p>
-            <a:pPr>
-              <a:defRPr sz="1300">
-                <a:solidFill>
-                  <a:srgbClr val="F5F7FA"/>
-                </a:solidFill>
-              </a:defRPr>
-            </a:pPr>
-            <a:r>
-              <a:t>Для запуска не требуется привлекать заемные средства или кредиты.</a:t>
-            </a:r>
-            <a:br/>
-            <a:r>
-              <a:t>Стартовый капитал в размере 1 500 000 ₸ формируется команда самостоятельно.</a:t>
+              <a:t>• Стартовый капитал в 1 500 000 ₸ формируется самостоятельно в течение полугода путем заработка на фриланс-биржах.</a:t>
             </a:r>
           </a:p>
         </p:txBody>

</xml_diff>